<commit_message>
feat: Cap nhat tin nhan chinh, custom dropdown AI chat, sua co che hoa da chuoi Duolingo va bao mat repo
</commit_message>
<xml_diff>
--- a/tổng kết sprint 1/SLIDE_THUYET_TRINH_SPRINT_1_THO_7_MAU.pptx
+++ b/tổng kết sprint 1/SLIDE_THUYET_TRINH_SPRINT_1_THO_7_MAU.pptx
@@ -4,23 +4,26 @@
   <p:sldMasterIdLst>
     <p:sldMasterId id="2147483648" r:id="rId1"/>
   </p:sldMasterIdLst>
+  <p:notesMasterIdLst>
+    <p:notesMasterId r:id="rId16"/>
+  </p:notesMasterIdLst>
   <p:sldIdLst>
-    <p:sldId id="256" r:id="rId7"/>
-    <p:sldId id="257" r:id="rId8"/>
-    <p:sldId id="258" r:id="rId9"/>
-    <p:sldId id="259" r:id="rId10"/>
-    <p:sldId id="260" r:id="rId11"/>
-    <p:sldId id="261" r:id="rId12"/>
-    <p:sldId id="262" r:id="rId13"/>
-    <p:sldId id="263" r:id="rId14"/>
-    <p:sldId id="264" r:id="rId15"/>
-    <p:sldId id="265" r:id="rId16"/>
-    <p:sldId id="266" r:id="rId17"/>
-    <p:sldId id="267" r:id="rId18"/>
-    <p:sldId id="268" r:id="rId19"/>
-    <p:sldId id="269" r:id="rId20"/>
+    <p:sldId id="256" r:id="rId2"/>
+    <p:sldId id="257" r:id="rId3"/>
+    <p:sldId id="258" r:id="rId4"/>
+    <p:sldId id="259" r:id="rId5"/>
+    <p:sldId id="260" r:id="rId6"/>
+    <p:sldId id="261" r:id="rId7"/>
+    <p:sldId id="262" r:id="rId8"/>
+    <p:sldId id="263" r:id="rId9"/>
+    <p:sldId id="264" r:id="rId10"/>
+    <p:sldId id="265" r:id="rId11"/>
+    <p:sldId id="266" r:id="rId12"/>
+    <p:sldId id="267" r:id="rId13"/>
+    <p:sldId id="268" r:id="rId14"/>
+    <p:sldId id="269" r:id="rId15"/>
   </p:sldIdLst>
-  <p:sldSz cx="12191695" cy="6858000" type="screen4x3"/>
+  <p:sldSz cx="12192000" cy="6858000"/>
   <p:notesSz cx="6858000" cy="9144000"/>
   <p:defaultTextStyle>
     <a:defPPr>
@@ -117,7 +120,544 @@
       </a:defRPr>
     </a:lvl9pPr>
   </p:defaultTextStyle>
+  <p:extLst>
+    <p:ext uri="{EFAFB233-063F-42B5-8137-9DF3F51BA10A}">
+      <p15:sldGuideLst xmlns:p15="http://schemas.microsoft.com/office/powerpoint/2012/main">
+        <p15:guide id="1" orient="horz" pos="2160">
+          <p15:clr>
+            <a:srgbClr val="A4A3A4"/>
+          </p15:clr>
+        </p15:guide>
+        <p15:guide id="2" pos="2880">
+          <p15:clr>
+            <a:srgbClr val="A4A3A4"/>
+          </p15:clr>
+        </p15:guide>
+      </p15:sldGuideLst>
+    </p:ext>
+  </p:extLst>
 </p:presentation>
+</file>
+
+<file path=ppt/notesMasters/notesMaster1.xml><?xml version="1.0" encoding="utf-8"?>
+<p:notesMaster xmlns:a="http://schemas.openxmlformats.org/drawingml/2006/main" xmlns:r="http://schemas.openxmlformats.org/officeDocument/2006/relationships" xmlns:p="http://schemas.openxmlformats.org/presentationml/2006/main">
+  <p:cSld>
+    <p:bg>
+      <p:bgRef idx="1001">
+        <a:schemeClr val="bg1"/>
+      </p:bgRef>
+    </p:bg>
+    <p:spTree>
+      <p:nvGrpSpPr>
+        <p:cNvPr id="1" name=""/>
+        <p:cNvGrpSpPr/>
+        <p:nvPr/>
+      </p:nvGrpSpPr>
+      <p:grpSpPr>
+        <a:xfrm>
+          <a:off x="0" y="0"/>
+          <a:ext cx="0" cy="0"/>
+          <a:chOff x="0" y="0"/>
+          <a:chExt cx="0" cy="0"/>
+        </a:xfrm>
+      </p:grpSpPr>
+      <p:sp>
+        <p:nvSpPr>
+          <p:cNvPr id="2" name="Header Placeholder 1"/>
+          <p:cNvSpPr>
+            <a:spLocks noGrp="1"/>
+          </p:cNvSpPr>
+          <p:nvPr>
+            <p:ph type="hdr" sz="quarter"/>
+          </p:nvPr>
+        </p:nvSpPr>
+        <p:spPr>
+          <a:xfrm>
+            <a:off x="0" y="0"/>
+            <a:ext cx="2971800" cy="458788"/>
+          </a:xfrm>
+          <a:prstGeom prst="rect">
+            <a:avLst/>
+          </a:prstGeom>
+        </p:spPr>
+        <p:txBody>
+          <a:bodyPr vert="horz" lIns="91440" tIns="45720" rIns="91440" bIns="45720" rtlCol="0"/>
+          <a:lstStyle>
+            <a:lvl1pPr algn="l">
+              <a:defRPr sz="1200"/>
+            </a:lvl1pPr>
+          </a:lstStyle>
+          <a:p>
+            <a:endParaRPr lang="en-US"/>
+          </a:p>
+        </p:txBody>
+      </p:sp>
+      <p:sp>
+        <p:nvSpPr>
+          <p:cNvPr id="3" name="Date Placeholder 2"/>
+          <p:cNvSpPr>
+            <a:spLocks noGrp="1"/>
+          </p:cNvSpPr>
+          <p:nvPr>
+            <p:ph type="dt" idx="1"/>
+          </p:nvPr>
+        </p:nvSpPr>
+        <p:spPr>
+          <a:xfrm>
+            <a:off x="3884613" y="0"/>
+            <a:ext cx="2971800" cy="458788"/>
+          </a:xfrm>
+          <a:prstGeom prst="rect">
+            <a:avLst/>
+          </a:prstGeom>
+        </p:spPr>
+        <p:txBody>
+          <a:bodyPr vert="horz" lIns="91440" tIns="45720" rIns="91440" bIns="45720" rtlCol="0"/>
+          <a:lstStyle>
+            <a:lvl1pPr algn="r">
+              <a:defRPr sz="1200"/>
+            </a:lvl1pPr>
+          </a:lstStyle>
+          <a:p>
+            <a:fld id="{E4FFE2C3-5028-41D0-B9D5-648B3D21AB63}" type="datetimeFigureOut">
+              <a:rPr lang="en-US" smtClean="0"/>
+              <a:t>10/22/2026</a:t>
+            </a:fld>
+            <a:endParaRPr lang="en-US"/>
+          </a:p>
+        </p:txBody>
+      </p:sp>
+      <p:sp>
+        <p:nvSpPr>
+          <p:cNvPr id="4" name="Slide Image Placeholder 3"/>
+          <p:cNvSpPr>
+            <a:spLocks noGrp="1" noRot="1" noChangeAspect="1"/>
+          </p:cNvSpPr>
+          <p:nvPr>
+            <p:ph type="sldImg" idx="2"/>
+          </p:nvPr>
+        </p:nvSpPr>
+        <p:spPr>
+          <a:xfrm>
+            <a:off x="685800" y="1143000"/>
+            <a:ext cx="5486400" cy="3086100"/>
+          </a:xfrm>
+          <a:prstGeom prst="rect">
+            <a:avLst/>
+          </a:prstGeom>
+          <a:noFill/>
+          <a:ln w="12700">
+            <a:solidFill>
+              <a:prstClr val="black"/>
+            </a:solidFill>
+          </a:ln>
+        </p:spPr>
+        <p:txBody>
+          <a:bodyPr vert="horz" lIns="91440" tIns="45720" rIns="91440" bIns="45720" rtlCol="0" anchor="ctr"/>
+          <a:lstStyle/>
+          <a:p>
+            <a:endParaRPr lang="en-US"/>
+          </a:p>
+        </p:txBody>
+      </p:sp>
+      <p:sp>
+        <p:nvSpPr>
+          <p:cNvPr id="5" name="Notes Placeholder 4"/>
+          <p:cNvSpPr>
+            <a:spLocks noGrp="1"/>
+          </p:cNvSpPr>
+          <p:nvPr>
+            <p:ph type="body" sz="quarter" idx="3"/>
+          </p:nvPr>
+        </p:nvSpPr>
+        <p:spPr>
+          <a:xfrm>
+            <a:off x="685800" y="4400550"/>
+            <a:ext cx="5486400" cy="3600450"/>
+          </a:xfrm>
+          <a:prstGeom prst="rect">
+            <a:avLst/>
+          </a:prstGeom>
+        </p:spPr>
+        <p:txBody>
+          <a:bodyPr vert="horz" lIns="91440" tIns="45720" rIns="91440" bIns="45720" rtlCol="0"/>
+          <a:lstStyle/>
+          <a:p>
+            <a:pPr lvl="0"/>
+            <a:r>
+              <a:rPr lang="en-US"/>
+              <a:t>Click to edit Master text styles</a:t>
+            </a:r>
+          </a:p>
+          <a:p>
+            <a:pPr lvl="1"/>
+            <a:r>
+              <a:rPr lang="en-US"/>
+              <a:t>Second level</a:t>
+            </a:r>
+          </a:p>
+          <a:p>
+            <a:pPr lvl="2"/>
+            <a:r>
+              <a:rPr lang="en-US"/>
+              <a:t>Third level</a:t>
+            </a:r>
+          </a:p>
+          <a:p>
+            <a:pPr lvl="3"/>
+            <a:r>
+              <a:rPr lang="en-US"/>
+              <a:t>Fourth level</a:t>
+            </a:r>
+          </a:p>
+          <a:p>
+            <a:pPr lvl="4"/>
+            <a:r>
+              <a:rPr lang="en-US"/>
+              <a:t>Fifth level</a:t>
+            </a:r>
+          </a:p>
+        </p:txBody>
+      </p:sp>
+      <p:sp>
+        <p:nvSpPr>
+          <p:cNvPr id="6" name="Footer Placeholder 5"/>
+          <p:cNvSpPr>
+            <a:spLocks noGrp="1"/>
+          </p:cNvSpPr>
+          <p:nvPr>
+            <p:ph type="ftr" sz="quarter" idx="4"/>
+          </p:nvPr>
+        </p:nvSpPr>
+        <p:spPr>
+          <a:xfrm>
+            <a:off x="0" y="8685213"/>
+            <a:ext cx="2971800" cy="458787"/>
+          </a:xfrm>
+          <a:prstGeom prst="rect">
+            <a:avLst/>
+          </a:prstGeom>
+        </p:spPr>
+        <p:txBody>
+          <a:bodyPr vert="horz" lIns="91440" tIns="45720" rIns="91440" bIns="45720" rtlCol="0" anchor="b"/>
+          <a:lstStyle>
+            <a:lvl1pPr algn="l">
+              <a:defRPr sz="1200"/>
+            </a:lvl1pPr>
+          </a:lstStyle>
+          <a:p>
+            <a:endParaRPr lang="en-US"/>
+          </a:p>
+        </p:txBody>
+      </p:sp>
+      <p:sp>
+        <p:nvSpPr>
+          <p:cNvPr id="7" name="Slide Number Placeholder 6"/>
+          <p:cNvSpPr>
+            <a:spLocks noGrp="1"/>
+          </p:cNvSpPr>
+          <p:nvPr>
+            <p:ph type="sldNum" sz="quarter" idx="5"/>
+          </p:nvPr>
+        </p:nvSpPr>
+        <p:spPr>
+          <a:xfrm>
+            <a:off x="3884613" y="8685213"/>
+            <a:ext cx="2971800" cy="458787"/>
+          </a:xfrm>
+          <a:prstGeom prst="rect">
+            <a:avLst/>
+          </a:prstGeom>
+        </p:spPr>
+        <p:txBody>
+          <a:bodyPr vert="horz" lIns="91440" tIns="45720" rIns="91440" bIns="45720" rtlCol="0" anchor="b"/>
+          <a:lstStyle>
+            <a:lvl1pPr algn="r">
+              <a:defRPr sz="1200"/>
+            </a:lvl1pPr>
+          </a:lstStyle>
+          <a:p>
+            <a:fld id="{4F2CA9D7-61EC-4561-9ACA-42AE9978C686}" type="slidenum">
+              <a:rPr lang="en-US" smtClean="0"/>
+              <a:t>‹#›</a:t>
+            </a:fld>
+            <a:endParaRPr lang="en-US"/>
+          </a:p>
+        </p:txBody>
+      </p:sp>
+    </p:spTree>
+    <p:extLst>
+      <p:ext uri="{BB962C8B-B14F-4D97-AF65-F5344CB8AC3E}">
+        <p14:creationId xmlns:p14="http://schemas.microsoft.com/office/powerpoint/2010/main" val="3938410787"/>
+      </p:ext>
+    </p:extLst>
+  </p:cSld>
+  <p:clrMap bg1="lt1" tx1="dk1" bg2="lt2" tx2="dk2" accent1="accent1" accent2="accent2" accent3="accent3" accent4="accent4" accent5="accent5" accent6="accent6" hlink="hlink" folHlink="folHlink"/>
+  <p:notesStyle>
+    <a:lvl1pPr marL="0" algn="l" defTabSz="914400" rtl="0" eaLnBrk="1" latinLnBrk="0" hangingPunct="1">
+      <a:defRPr sz="1200" kern="1200">
+        <a:solidFill>
+          <a:schemeClr val="tx1"/>
+        </a:solidFill>
+        <a:latin typeface="+mn-lt"/>
+        <a:ea typeface="+mn-ea"/>
+        <a:cs typeface="+mn-cs"/>
+      </a:defRPr>
+    </a:lvl1pPr>
+    <a:lvl2pPr marL="457200" algn="l" defTabSz="914400" rtl="0" eaLnBrk="1" latinLnBrk="0" hangingPunct="1">
+      <a:defRPr sz="1200" kern="1200">
+        <a:solidFill>
+          <a:schemeClr val="tx1"/>
+        </a:solidFill>
+        <a:latin typeface="+mn-lt"/>
+        <a:ea typeface="+mn-ea"/>
+        <a:cs typeface="+mn-cs"/>
+      </a:defRPr>
+    </a:lvl2pPr>
+    <a:lvl3pPr marL="914400" algn="l" defTabSz="914400" rtl="0" eaLnBrk="1" latinLnBrk="0" hangingPunct="1">
+      <a:defRPr sz="1200" kern="1200">
+        <a:solidFill>
+          <a:schemeClr val="tx1"/>
+        </a:solidFill>
+        <a:latin typeface="+mn-lt"/>
+        <a:ea typeface="+mn-ea"/>
+        <a:cs typeface="+mn-cs"/>
+      </a:defRPr>
+    </a:lvl3pPr>
+    <a:lvl4pPr marL="1371600" algn="l" defTabSz="914400" rtl="0" eaLnBrk="1" latinLnBrk="0" hangingPunct="1">
+      <a:defRPr sz="1200" kern="1200">
+        <a:solidFill>
+          <a:schemeClr val="tx1"/>
+        </a:solidFill>
+        <a:latin typeface="+mn-lt"/>
+        <a:ea typeface="+mn-ea"/>
+        <a:cs typeface="+mn-cs"/>
+      </a:defRPr>
+    </a:lvl4pPr>
+    <a:lvl5pPr marL="1828800" algn="l" defTabSz="914400" rtl="0" eaLnBrk="1" latinLnBrk="0" hangingPunct="1">
+      <a:defRPr sz="1200" kern="1200">
+        <a:solidFill>
+          <a:schemeClr val="tx1"/>
+        </a:solidFill>
+        <a:latin typeface="+mn-lt"/>
+        <a:ea typeface="+mn-ea"/>
+        <a:cs typeface="+mn-cs"/>
+      </a:defRPr>
+    </a:lvl5pPr>
+    <a:lvl6pPr marL="2286000" algn="l" defTabSz="914400" rtl="0" eaLnBrk="1" latinLnBrk="0" hangingPunct="1">
+      <a:defRPr sz="1200" kern="1200">
+        <a:solidFill>
+          <a:schemeClr val="tx1"/>
+        </a:solidFill>
+        <a:latin typeface="+mn-lt"/>
+        <a:ea typeface="+mn-ea"/>
+        <a:cs typeface="+mn-cs"/>
+      </a:defRPr>
+    </a:lvl6pPr>
+    <a:lvl7pPr marL="2743200" algn="l" defTabSz="914400" rtl="0" eaLnBrk="1" latinLnBrk="0" hangingPunct="1">
+      <a:defRPr sz="1200" kern="1200">
+        <a:solidFill>
+          <a:schemeClr val="tx1"/>
+        </a:solidFill>
+        <a:latin typeface="+mn-lt"/>
+        <a:ea typeface="+mn-ea"/>
+        <a:cs typeface="+mn-cs"/>
+      </a:defRPr>
+    </a:lvl7pPr>
+    <a:lvl8pPr marL="3200400" algn="l" defTabSz="914400" rtl="0" eaLnBrk="1" latinLnBrk="0" hangingPunct="1">
+      <a:defRPr sz="1200" kern="1200">
+        <a:solidFill>
+          <a:schemeClr val="tx1"/>
+        </a:solidFill>
+        <a:latin typeface="+mn-lt"/>
+        <a:ea typeface="+mn-ea"/>
+        <a:cs typeface="+mn-cs"/>
+      </a:defRPr>
+    </a:lvl8pPr>
+    <a:lvl9pPr marL="3657600" algn="l" defTabSz="914400" rtl="0" eaLnBrk="1" latinLnBrk="0" hangingPunct="1">
+      <a:defRPr sz="1200" kern="1200">
+        <a:solidFill>
+          <a:schemeClr val="tx1"/>
+        </a:solidFill>
+        <a:latin typeface="+mn-lt"/>
+        <a:ea typeface="+mn-ea"/>
+        <a:cs typeface="+mn-cs"/>
+      </a:defRPr>
+    </a:lvl9pPr>
+  </p:notesStyle>
+</p:notesMaster>
+</file>
+
+<file path=ppt/notesSlides/notesSlide1.xml><?xml version="1.0" encoding="utf-8"?>
+<p:notes xmlns:a="http://schemas.openxmlformats.org/drawingml/2006/main" xmlns:r="http://schemas.openxmlformats.org/officeDocument/2006/relationships" xmlns:p="http://schemas.openxmlformats.org/presentationml/2006/main">
+  <p:cSld>
+    <p:spTree>
+      <p:nvGrpSpPr>
+        <p:cNvPr id="1" name=""/>
+        <p:cNvGrpSpPr/>
+        <p:nvPr/>
+      </p:nvGrpSpPr>
+      <p:grpSpPr>
+        <a:xfrm>
+          <a:off x="0" y="0"/>
+          <a:ext cx="0" cy="0"/>
+          <a:chOff x="0" y="0"/>
+          <a:chExt cx="0" cy="0"/>
+        </a:xfrm>
+      </p:grpSpPr>
+      <p:sp>
+        <p:nvSpPr>
+          <p:cNvPr id="2" name="Slide Image Placeholder 1"/>
+          <p:cNvSpPr>
+            <a:spLocks noGrp="1" noRot="1" noChangeAspect="1"/>
+          </p:cNvSpPr>
+          <p:nvPr>
+            <p:ph type="sldImg"/>
+          </p:nvPr>
+        </p:nvSpPr>
+        <p:spPr/>
+      </p:sp>
+      <p:sp>
+        <p:nvSpPr>
+          <p:cNvPr id="3" name="Notes Placeholder 2"/>
+          <p:cNvSpPr>
+            <a:spLocks noGrp="1"/>
+          </p:cNvSpPr>
+          <p:nvPr>
+            <p:ph type="body" idx="1"/>
+          </p:nvPr>
+        </p:nvSpPr>
+        <p:spPr/>
+        <p:txBody>
+          <a:bodyPr/>
+          <a:lstStyle/>
+          <a:p>
+            <a:endParaRPr lang="en-US" dirty="0"/>
+          </a:p>
+        </p:txBody>
+      </p:sp>
+      <p:sp>
+        <p:nvSpPr>
+          <p:cNvPr id="4" name="Slide Number Placeholder 3"/>
+          <p:cNvSpPr>
+            <a:spLocks noGrp="1"/>
+          </p:cNvSpPr>
+          <p:nvPr>
+            <p:ph type="sldNum" sz="quarter" idx="5"/>
+          </p:nvPr>
+        </p:nvSpPr>
+        <p:spPr/>
+        <p:txBody>
+          <a:bodyPr/>
+          <a:lstStyle/>
+          <a:p>
+            <a:fld id="{4F2CA9D7-61EC-4561-9ACA-42AE9978C686}" type="slidenum">
+              <a:rPr lang="en-US" smtClean="0"/>
+              <a:t>3</a:t>
+            </a:fld>
+            <a:endParaRPr lang="en-US"/>
+          </a:p>
+        </p:txBody>
+      </p:sp>
+    </p:spTree>
+    <p:extLst>
+      <p:ext uri="{BB962C8B-B14F-4D97-AF65-F5344CB8AC3E}">
+        <p14:creationId xmlns:p14="http://schemas.microsoft.com/office/powerpoint/2010/main" val="2686788615"/>
+      </p:ext>
+    </p:extLst>
+  </p:cSld>
+  <p:clrMapOvr>
+    <a:masterClrMapping/>
+  </p:clrMapOvr>
+</p:notes>
+</file>
+
+<file path=ppt/notesSlides/notesSlide2.xml><?xml version="1.0" encoding="utf-8"?>
+<p:notes xmlns:a="http://schemas.openxmlformats.org/drawingml/2006/main" xmlns:r="http://schemas.openxmlformats.org/officeDocument/2006/relationships" xmlns:p="http://schemas.openxmlformats.org/presentationml/2006/main">
+  <p:cSld>
+    <p:spTree>
+      <p:nvGrpSpPr>
+        <p:cNvPr id="1" name=""/>
+        <p:cNvGrpSpPr/>
+        <p:nvPr/>
+      </p:nvGrpSpPr>
+      <p:grpSpPr>
+        <a:xfrm>
+          <a:off x="0" y="0"/>
+          <a:ext cx="0" cy="0"/>
+          <a:chOff x="0" y="0"/>
+          <a:chExt cx="0" cy="0"/>
+        </a:xfrm>
+      </p:grpSpPr>
+      <p:sp>
+        <p:nvSpPr>
+          <p:cNvPr id="2" name="Slide Image Placeholder 1"/>
+          <p:cNvSpPr>
+            <a:spLocks noGrp="1" noRot="1" noChangeAspect="1"/>
+          </p:cNvSpPr>
+          <p:nvPr>
+            <p:ph type="sldImg"/>
+          </p:nvPr>
+        </p:nvSpPr>
+        <p:spPr/>
+      </p:sp>
+      <p:sp>
+        <p:nvSpPr>
+          <p:cNvPr id="3" name="Notes Placeholder 2"/>
+          <p:cNvSpPr>
+            <a:spLocks noGrp="1"/>
+          </p:cNvSpPr>
+          <p:nvPr>
+            <p:ph type="body" idx="1"/>
+          </p:nvPr>
+        </p:nvSpPr>
+        <p:spPr/>
+        <p:txBody>
+          <a:bodyPr/>
+          <a:lstStyle/>
+          <a:p>
+            <a:r>
+              <a:rPr lang="vi-VN" dirty="0"/>
+              <a:t>Thêm phần thầy cô biết ghi nhận cộng điểm</a:t>
+            </a:r>
+            <a:endParaRPr lang="en-US" dirty="0"/>
+          </a:p>
+        </p:txBody>
+      </p:sp>
+      <p:sp>
+        <p:nvSpPr>
+          <p:cNvPr id="4" name="Slide Number Placeholder 3"/>
+          <p:cNvSpPr>
+            <a:spLocks noGrp="1"/>
+          </p:cNvSpPr>
+          <p:nvPr>
+            <p:ph type="sldNum" sz="quarter" idx="5"/>
+          </p:nvPr>
+        </p:nvSpPr>
+        <p:spPr/>
+        <p:txBody>
+          <a:bodyPr/>
+          <a:lstStyle/>
+          <a:p>
+            <a:fld id="{4F2CA9D7-61EC-4561-9ACA-42AE9978C686}" type="slidenum">
+              <a:rPr lang="en-US" smtClean="0"/>
+              <a:t>5</a:t>
+            </a:fld>
+            <a:endParaRPr lang="en-US"/>
+          </a:p>
+        </p:txBody>
+      </p:sp>
+    </p:spTree>
+    <p:extLst>
+      <p:ext uri="{BB962C8B-B14F-4D97-AF65-F5344CB8AC3E}">
+        <p14:creationId xmlns:p14="http://schemas.microsoft.com/office/powerpoint/2010/main" val="2419598438"/>
+      </p:ext>
+    </p:extLst>
+  </p:cSld>
+  <p:clrMapOvr>
+    <a:masterClrMapping/>
+  </p:clrMapOvr>
+</p:notes>
 </file>
 
 <file path=ppt/slideLayouts/slideLayout1.xml><?xml version="1.0" encoding="utf-8"?>
@@ -158,10 +698,9 @@
           <a:lstStyle/>
           <a:p>
             <a:r>
-              <a:rPr lang="en-US" smtClean="0"/>
+              <a:rPr lang="en-US"/>
               <a:t>Click to edit Master title style</a:t>
             </a:r>
-            <a:endParaRPr lang="en-US"/>
           </a:p>
         </p:txBody>
       </p:sp>
@@ -277,10 +816,9 @@
           </a:lstStyle>
           <a:p>
             <a:r>
-              <a:rPr lang="en-US" smtClean="0"/>
+              <a:rPr lang="en-US"/>
               <a:t>Click to edit Master subtitle style</a:t>
             </a:r>
-            <a:endParaRPr lang="en-US"/>
           </a:p>
         </p:txBody>
       </p:sp>
@@ -301,7 +839,7 @@
           <a:p>
             <a:fld id="{5BCAD085-E8A6-8845-BD4E-CB4CCA059FC4}" type="datetimeFigureOut">
               <a:rPr lang="en-US" smtClean="0"/>
-              <a:t>1/27/13</a:t>
+              <a:t>10/22/2026</a:t>
             </a:fld>
             <a:endParaRPr lang="en-US"/>
           </a:p>
@@ -395,10 +933,9 @@
           <a:lstStyle/>
           <a:p>
             <a:r>
-              <a:rPr lang="en-US" smtClean="0"/>
+              <a:rPr lang="en-US"/>
               <a:t>Click to edit Master title style</a:t>
             </a:r>
-            <a:endParaRPr lang="en-US"/>
           </a:p>
         </p:txBody>
       </p:sp>
@@ -419,38 +956,37 @@
           <a:p>
             <a:pPr lvl="0"/>
             <a:r>
-              <a:rPr lang="en-US" smtClean="0"/>
+              <a:rPr lang="en-US"/>
               <a:t>Click to edit Master text styles</a:t>
             </a:r>
           </a:p>
           <a:p>
             <a:pPr lvl="1"/>
             <a:r>
-              <a:rPr lang="en-US" smtClean="0"/>
+              <a:rPr lang="en-US"/>
               <a:t>Second level</a:t>
             </a:r>
           </a:p>
           <a:p>
             <a:pPr lvl="2"/>
             <a:r>
-              <a:rPr lang="en-US" smtClean="0"/>
+              <a:rPr lang="en-US"/>
               <a:t>Third level</a:t>
             </a:r>
           </a:p>
           <a:p>
             <a:pPr lvl="3"/>
             <a:r>
-              <a:rPr lang="en-US" smtClean="0"/>
+              <a:rPr lang="en-US"/>
               <a:t>Fourth level</a:t>
             </a:r>
           </a:p>
           <a:p>
             <a:pPr lvl="4"/>
             <a:r>
-              <a:rPr lang="en-US" smtClean="0"/>
+              <a:rPr lang="en-US"/>
               <a:t>Fifth level</a:t>
             </a:r>
-            <a:endParaRPr lang="en-US"/>
           </a:p>
         </p:txBody>
       </p:sp>
@@ -471,7 +1007,7 @@
           <a:p>
             <a:fld id="{5BCAD085-E8A6-8845-BD4E-CB4CCA059FC4}" type="datetimeFigureOut">
               <a:rPr lang="en-US" smtClean="0"/>
-              <a:t>1/27/13</a:t>
+              <a:t>10/22/2026</a:t>
             </a:fld>
             <a:endParaRPr lang="en-US"/>
           </a:p>
@@ -570,10 +1106,9 @@
           <a:lstStyle/>
           <a:p>
             <a:r>
-              <a:rPr lang="en-US" smtClean="0"/>
+              <a:rPr lang="en-US"/>
               <a:t>Click to edit Master title style</a:t>
             </a:r>
-            <a:endParaRPr lang="en-US"/>
           </a:p>
         </p:txBody>
       </p:sp>
@@ -599,38 +1134,37 @@
           <a:p>
             <a:pPr lvl="0"/>
             <a:r>
-              <a:rPr lang="en-US" smtClean="0"/>
+              <a:rPr lang="en-US"/>
               <a:t>Click to edit Master text styles</a:t>
             </a:r>
           </a:p>
           <a:p>
             <a:pPr lvl="1"/>
             <a:r>
-              <a:rPr lang="en-US" smtClean="0"/>
+              <a:rPr lang="en-US"/>
               <a:t>Second level</a:t>
             </a:r>
           </a:p>
           <a:p>
             <a:pPr lvl="2"/>
             <a:r>
-              <a:rPr lang="en-US" smtClean="0"/>
+              <a:rPr lang="en-US"/>
               <a:t>Third level</a:t>
             </a:r>
           </a:p>
           <a:p>
             <a:pPr lvl="3"/>
             <a:r>
-              <a:rPr lang="en-US" smtClean="0"/>
+              <a:rPr lang="en-US"/>
               <a:t>Fourth level</a:t>
             </a:r>
           </a:p>
           <a:p>
             <a:pPr lvl="4"/>
             <a:r>
-              <a:rPr lang="en-US" smtClean="0"/>
+              <a:rPr lang="en-US"/>
               <a:t>Fifth level</a:t>
             </a:r>
-            <a:endParaRPr lang="en-US"/>
           </a:p>
         </p:txBody>
       </p:sp>
@@ -651,7 +1185,7 @@
           <a:p>
             <a:fld id="{5BCAD085-E8A6-8845-BD4E-CB4CCA059FC4}" type="datetimeFigureOut">
               <a:rPr lang="en-US" smtClean="0"/>
-              <a:t>1/27/13</a:t>
+              <a:t>10/22/2026</a:t>
             </a:fld>
             <a:endParaRPr lang="en-US"/>
           </a:p>
@@ -745,10 +1279,9 @@
           <a:lstStyle/>
           <a:p>
             <a:r>
-              <a:rPr lang="en-US" smtClean="0"/>
+              <a:rPr lang="en-US"/>
               <a:t>Click to edit Master title style</a:t>
             </a:r>
-            <a:endParaRPr lang="en-US"/>
           </a:p>
         </p:txBody>
       </p:sp>
@@ -769,38 +1302,37 @@
           <a:p>
             <a:pPr lvl="0"/>
             <a:r>
-              <a:rPr lang="en-US" smtClean="0"/>
+              <a:rPr lang="en-US"/>
               <a:t>Click to edit Master text styles</a:t>
             </a:r>
           </a:p>
           <a:p>
             <a:pPr lvl="1"/>
             <a:r>
-              <a:rPr lang="en-US" smtClean="0"/>
+              <a:rPr lang="en-US"/>
               <a:t>Second level</a:t>
             </a:r>
           </a:p>
           <a:p>
             <a:pPr lvl="2"/>
             <a:r>
-              <a:rPr lang="en-US" smtClean="0"/>
+              <a:rPr lang="en-US"/>
               <a:t>Third level</a:t>
             </a:r>
           </a:p>
           <a:p>
             <a:pPr lvl="3"/>
             <a:r>
-              <a:rPr lang="en-US" smtClean="0"/>
+              <a:rPr lang="en-US"/>
               <a:t>Fourth level</a:t>
             </a:r>
           </a:p>
           <a:p>
             <a:pPr lvl="4"/>
             <a:r>
-              <a:rPr lang="en-US" smtClean="0"/>
+              <a:rPr lang="en-US"/>
               <a:t>Fifth level</a:t>
             </a:r>
-            <a:endParaRPr lang="en-US"/>
           </a:p>
         </p:txBody>
       </p:sp>
@@ -821,7 +1353,7 @@
           <a:p>
             <a:fld id="{5BCAD085-E8A6-8845-BD4E-CB4CCA059FC4}" type="datetimeFigureOut">
               <a:rPr lang="en-US" smtClean="0"/>
-              <a:t>1/27/13</a:t>
+              <a:t>10/22/2026</a:t>
             </a:fld>
             <a:endParaRPr lang="en-US"/>
           </a:p>
@@ -924,10 +1456,9 @@
           </a:lstStyle>
           <a:p>
             <a:r>
-              <a:rPr lang="en-US" smtClean="0"/>
+              <a:rPr lang="en-US"/>
               <a:t>Click to edit Master title style</a:t>
             </a:r>
-            <a:endParaRPr lang="en-US"/>
           </a:p>
         </p:txBody>
       </p:sp>
@@ -1044,7 +1575,7 @@
           <a:p>
             <a:pPr lvl="0"/>
             <a:r>
-              <a:rPr lang="en-US" smtClean="0"/>
+              <a:rPr lang="en-US"/>
               <a:t>Click to edit Master text styles</a:t>
             </a:r>
           </a:p>
@@ -1067,7 +1598,7 @@
           <a:p>
             <a:fld id="{5BCAD085-E8A6-8845-BD4E-CB4CCA059FC4}" type="datetimeFigureOut">
               <a:rPr lang="en-US" smtClean="0"/>
-              <a:t>1/27/13</a:t>
+              <a:t>10/22/2026</a:t>
             </a:fld>
             <a:endParaRPr lang="en-US"/>
           </a:p>
@@ -1161,10 +1692,9 @@
           <a:lstStyle/>
           <a:p>
             <a:r>
-              <a:rPr lang="en-US" smtClean="0"/>
+              <a:rPr lang="en-US"/>
               <a:t>Click to edit Master title style</a:t>
             </a:r>
-            <a:endParaRPr lang="en-US"/>
           </a:p>
         </p:txBody>
       </p:sp>
@@ -1218,38 +1748,37 @@
           <a:p>
             <a:pPr lvl="0"/>
             <a:r>
-              <a:rPr lang="en-US" smtClean="0"/>
+              <a:rPr lang="en-US"/>
               <a:t>Click to edit Master text styles</a:t>
             </a:r>
           </a:p>
           <a:p>
             <a:pPr lvl="1"/>
             <a:r>
-              <a:rPr lang="en-US" smtClean="0"/>
+              <a:rPr lang="en-US"/>
               <a:t>Second level</a:t>
             </a:r>
           </a:p>
           <a:p>
             <a:pPr lvl="2"/>
             <a:r>
-              <a:rPr lang="en-US" smtClean="0"/>
+              <a:rPr lang="en-US"/>
               <a:t>Third level</a:t>
             </a:r>
           </a:p>
           <a:p>
             <a:pPr lvl="3"/>
             <a:r>
-              <a:rPr lang="en-US" smtClean="0"/>
+              <a:rPr lang="en-US"/>
               <a:t>Fourth level</a:t>
             </a:r>
           </a:p>
           <a:p>
             <a:pPr lvl="4"/>
             <a:r>
-              <a:rPr lang="en-US" smtClean="0"/>
+              <a:rPr lang="en-US"/>
               <a:t>Fifth level</a:t>
             </a:r>
-            <a:endParaRPr lang="en-US"/>
           </a:p>
         </p:txBody>
       </p:sp>
@@ -1303,38 +1832,37 @@
           <a:p>
             <a:pPr lvl="0"/>
             <a:r>
-              <a:rPr lang="en-US" smtClean="0"/>
+              <a:rPr lang="en-US"/>
               <a:t>Click to edit Master text styles</a:t>
             </a:r>
           </a:p>
           <a:p>
             <a:pPr lvl="1"/>
             <a:r>
-              <a:rPr lang="en-US" smtClean="0"/>
+              <a:rPr lang="en-US"/>
               <a:t>Second level</a:t>
             </a:r>
           </a:p>
           <a:p>
             <a:pPr lvl="2"/>
             <a:r>
-              <a:rPr lang="en-US" smtClean="0"/>
+              <a:rPr lang="en-US"/>
               <a:t>Third level</a:t>
             </a:r>
           </a:p>
           <a:p>
             <a:pPr lvl="3"/>
             <a:r>
-              <a:rPr lang="en-US" smtClean="0"/>
+              <a:rPr lang="en-US"/>
               <a:t>Fourth level</a:t>
             </a:r>
           </a:p>
           <a:p>
             <a:pPr lvl="4"/>
             <a:r>
-              <a:rPr lang="en-US" smtClean="0"/>
+              <a:rPr lang="en-US"/>
               <a:t>Fifth level</a:t>
             </a:r>
-            <a:endParaRPr lang="en-US"/>
           </a:p>
         </p:txBody>
       </p:sp>
@@ -1355,7 +1883,7 @@
           <a:p>
             <a:fld id="{5BCAD085-E8A6-8845-BD4E-CB4CCA059FC4}" type="datetimeFigureOut">
               <a:rPr lang="en-US" smtClean="0"/>
-              <a:t>1/27/13</a:t>
+              <a:t>10/22/2026</a:t>
             </a:fld>
             <a:endParaRPr lang="en-US"/>
           </a:p>
@@ -1453,10 +1981,9 @@
           </a:lstStyle>
           <a:p>
             <a:r>
-              <a:rPr lang="en-US" smtClean="0"/>
+              <a:rPr lang="en-US"/>
               <a:t>Click to edit Master title style</a:t>
             </a:r>
-            <a:endParaRPr lang="en-US"/>
           </a:p>
         </p:txBody>
       </p:sp>
@@ -1519,7 +2046,7 @@
           <a:p>
             <a:pPr lvl="0"/>
             <a:r>
-              <a:rPr lang="en-US" smtClean="0"/>
+              <a:rPr lang="en-US"/>
               <a:t>Click to edit Master text styles</a:t>
             </a:r>
           </a:p>
@@ -1575,38 +2102,37 @@
           <a:p>
             <a:pPr lvl="0"/>
             <a:r>
-              <a:rPr lang="en-US" smtClean="0"/>
+              <a:rPr lang="en-US"/>
               <a:t>Click to edit Master text styles</a:t>
             </a:r>
           </a:p>
           <a:p>
             <a:pPr lvl="1"/>
             <a:r>
-              <a:rPr lang="en-US" smtClean="0"/>
+              <a:rPr lang="en-US"/>
               <a:t>Second level</a:t>
             </a:r>
           </a:p>
           <a:p>
             <a:pPr lvl="2"/>
             <a:r>
-              <a:rPr lang="en-US" smtClean="0"/>
+              <a:rPr lang="en-US"/>
               <a:t>Third level</a:t>
             </a:r>
           </a:p>
           <a:p>
             <a:pPr lvl="3"/>
             <a:r>
-              <a:rPr lang="en-US" smtClean="0"/>
+              <a:rPr lang="en-US"/>
               <a:t>Fourth level</a:t>
             </a:r>
           </a:p>
           <a:p>
             <a:pPr lvl="4"/>
             <a:r>
-              <a:rPr lang="en-US" smtClean="0"/>
+              <a:rPr lang="en-US"/>
               <a:t>Fifth level</a:t>
             </a:r>
-            <a:endParaRPr lang="en-US"/>
           </a:p>
         </p:txBody>
       </p:sp>
@@ -1669,7 +2195,7 @@
           <a:p>
             <a:pPr lvl="0"/>
             <a:r>
-              <a:rPr lang="en-US" smtClean="0"/>
+              <a:rPr lang="en-US"/>
               <a:t>Click to edit Master text styles</a:t>
             </a:r>
           </a:p>
@@ -1725,38 +2251,37 @@
           <a:p>
             <a:pPr lvl="0"/>
             <a:r>
-              <a:rPr lang="en-US" smtClean="0"/>
+              <a:rPr lang="en-US"/>
               <a:t>Click to edit Master text styles</a:t>
             </a:r>
           </a:p>
           <a:p>
             <a:pPr lvl="1"/>
             <a:r>
-              <a:rPr lang="en-US" smtClean="0"/>
+              <a:rPr lang="en-US"/>
               <a:t>Second level</a:t>
             </a:r>
           </a:p>
           <a:p>
             <a:pPr lvl="2"/>
             <a:r>
-              <a:rPr lang="en-US" smtClean="0"/>
+              <a:rPr lang="en-US"/>
               <a:t>Third level</a:t>
             </a:r>
           </a:p>
           <a:p>
             <a:pPr lvl="3"/>
             <a:r>
-              <a:rPr lang="en-US" smtClean="0"/>
+              <a:rPr lang="en-US"/>
               <a:t>Fourth level</a:t>
             </a:r>
           </a:p>
           <a:p>
             <a:pPr lvl="4"/>
             <a:r>
-              <a:rPr lang="en-US" smtClean="0"/>
+              <a:rPr lang="en-US"/>
               <a:t>Fifth level</a:t>
             </a:r>
-            <a:endParaRPr lang="en-US"/>
           </a:p>
         </p:txBody>
       </p:sp>
@@ -1777,7 +2302,7 @@
           <a:p>
             <a:fld id="{5BCAD085-E8A6-8845-BD4E-CB4CCA059FC4}" type="datetimeFigureOut">
               <a:rPr lang="en-US" smtClean="0"/>
-              <a:t>1/27/13</a:t>
+              <a:t>10/22/2026</a:t>
             </a:fld>
             <a:endParaRPr lang="en-US"/>
           </a:p>
@@ -1871,10 +2396,9 @@
           <a:lstStyle/>
           <a:p>
             <a:r>
-              <a:rPr lang="en-US" smtClean="0"/>
+              <a:rPr lang="en-US"/>
               <a:t>Click to edit Master title style</a:t>
             </a:r>
-            <a:endParaRPr lang="en-US"/>
           </a:p>
         </p:txBody>
       </p:sp>
@@ -1895,7 +2419,7 @@
           <a:p>
             <a:fld id="{5BCAD085-E8A6-8845-BD4E-CB4CCA059FC4}" type="datetimeFigureOut">
               <a:rPr lang="en-US" smtClean="0"/>
-              <a:t>1/27/13</a:t>
+              <a:t>10/22/2026</a:t>
             </a:fld>
             <a:endParaRPr lang="en-US"/>
           </a:p>
@@ -1990,7 +2514,7 @@
           <a:p>
             <a:fld id="{5BCAD085-E8A6-8845-BD4E-CB4CCA059FC4}" type="datetimeFigureOut">
               <a:rPr lang="en-US" smtClean="0"/>
-              <a:t>1/27/13</a:t>
+              <a:t>10/22/2026</a:t>
             </a:fld>
             <a:endParaRPr lang="en-US"/>
           </a:p>
@@ -2093,10 +2617,9 @@
           </a:lstStyle>
           <a:p>
             <a:r>
-              <a:rPr lang="en-US" smtClean="0"/>
+              <a:rPr lang="en-US"/>
               <a:t>Click to edit Master title style</a:t>
             </a:r>
-            <a:endParaRPr lang="en-US"/>
           </a:p>
         </p:txBody>
       </p:sp>
@@ -2150,38 +2673,37 @@
           <a:p>
             <a:pPr lvl="0"/>
             <a:r>
-              <a:rPr lang="en-US" smtClean="0"/>
+              <a:rPr lang="en-US"/>
               <a:t>Click to edit Master text styles</a:t>
             </a:r>
           </a:p>
           <a:p>
             <a:pPr lvl="1"/>
             <a:r>
-              <a:rPr lang="en-US" smtClean="0"/>
+              <a:rPr lang="en-US"/>
               <a:t>Second level</a:t>
             </a:r>
           </a:p>
           <a:p>
             <a:pPr lvl="2"/>
             <a:r>
-              <a:rPr lang="en-US" smtClean="0"/>
+              <a:rPr lang="en-US"/>
               <a:t>Third level</a:t>
             </a:r>
           </a:p>
           <a:p>
             <a:pPr lvl="3"/>
             <a:r>
-              <a:rPr lang="en-US" smtClean="0"/>
+              <a:rPr lang="en-US"/>
               <a:t>Fourth level</a:t>
             </a:r>
           </a:p>
           <a:p>
             <a:pPr lvl="4"/>
             <a:r>
-              <a:rPr lang="en-US" smtClean="0"/>
+              <a:rPr lang="en-US"/>
               <a:t>Fifth level</a:t>
             </a:r>
-            <a:endParaRPr lang="en-US"/>
           </a:p>
         </p:txBody>
       </p:sp>
@@ -2244,7 +2766,7 @@
           <a:p>
             <a:pPr lvl="0"/>
             <a:r>
-              <a:rPr lang="en-US" smtClean="0"/>
+              <a:rPr lang="en-US"/>
               <a:t>Click to edit Master text styles</a:t>
             </a:r>
           </a:p>
@@ -2267,7 +2789,7 @@
           <a:p>
             <a:fld id="{5BCAD085-E8A6-8845-BD4E-CB4CCA059FC4}" type="datetimeFigureOut">
               <a:rPr lang="en-US" smtClean="0"/>
-              <a:t>1/27/13</a:t>
+              <a:t>10/22/2026</a:t>
             </a:fld>
             <a:endParaRPr lang="en-US"/>
           </a:p>
@@ -2370,10 +2892,9 @@
           </a:lstStyle>
           <a:p>
             <a:r>
-              <a:rPr lang="en-US" smtClean="0"/>
+              <a:rPr lang="en-US"/>
               <a:t>Click to edit Master title style</a:t>
             </a:r>
-            <a:endParaRPr lang="en-US"/>
           </a:p>
         </p:txBody>
       </p:sp>
@@ -2497,7 +3018,7 @@
           <a:p>
             <a:pPr lvl="0"/>
             <a:r>
-              <a:rPr lang="en-US" smtClean="0"/>
+              <a:rPr lang="en-US"/>
               <a:t>Click to edit Master text styles</a:t>
             </a:r>
           </a:p>
@@ -2520,7 +3041,7 @@
           <a:p>
             <a:fld id="{5BCAD085-E8A6-8845-BD4E-CB4CCA059FC4}" type="datetimeFigureOut">
               <a:rPr lang="en-US" smtClean="0"/>
-              <a:t>1/27/13</a:t>
+              <a:t>10/22/2026</a:t>
             </a:fld>
             <a:endParaRPr lang="en-US"/>
           </a:p>
@@ -2629,10 +3150,9 @@
           <a:lstStyle/>
           <a:p>
             <a:r>
-              <a:rPr lang="en-US" smtClean="0"/>
+              <a:rPr lang="en-US"/>
               <a:t>Click to edit Master title style</a:t>
             </a:r>
-            <a:endParaRPr lang="en-US"/>
           </a:p>
         </p:txBody>
       </p:sp>
@@ -2663,38 +3183,37 @@
           <a:p>
             <a:pPr lvl="0"/>
             <a:r>
-              <a:rPr lang="en-US" smtClean="0"/>
+              <a:rPr lang="en-US"/>
               <a:t>Click to edit Master text styles</a:t>
             </a:r>
           </a:p>
           <a:p>
             <a:pPr lvl="1"/>
             <a:r>
-              <a:rPr lang="en-US" smtClean="0"/>
+              <a:rPr lang="en-US"/>
               <a:t>Second level</a:t>
             </a:r>
           </a:p>
           <a:p>
             <a:pPr lvl="2"/>
             <a:r>
-              <a:rPr lang="en-US" smtClean="0"/>
+              <a:rPr lang="en-US"/>
               <a:t>Third level</a:t>
             </a:r>
           </a:p>
           <a:p>
             <a:pPr lvl="3"/>
             <a:r>
-              <a:rPr lang="en-US" smtClean="0"/>
+              <a:rPr lang="en-US"/>
               <a:t>Fourth level</a:t>
             </a:r>
           </a:p>
           <a:p>
             <a:pPr lvl="4"/>
             <a:r>
-              <a:rPr lang="en-US" smtClean="0"/>
+              <a:rPr lang="en-US"/>
               <a:t>Fifth level</a:t>
             </a:r>
-            <a:endParaRPr lang="en-US"/>
           </a:p>
         </p:txBody>
       </p:sp>
@@ -2733,7 +3252,7 @@
           <a:p>
             <a:fld id="{5BCAD085-E8A6-8845-BD4E-CB4CCA059FC4}" type="datetimeFigureOut">
               <a:rPr lang="en-US" smtClean="0"/>
-              <a:t>1/27/13</a:t>
+              <a:t>10/22/2026</a:t>
             </a:fld>
             <a:endParaRPr lang="en-US"/>
           </a:p>
@@ -3092,7 +3611,7 @@
 </file>
 
 <file path=ppt/slides/slide1.xml><?xml version="1.0" encoding="utf-8"?>
-<p:sld xmlns:a="http://schemas.openxmlformats.org/drawingml/2006/main" xmlns:p="http://schemas.openxmlformats.org/presentationml/2006/main" xmlns:r="http://schemas.openxmlformats.org/officeDocument/2006/relationships">
+<p:sld xmlns:a="http://schemas.openxmlformats.org/drawingml/2006/main" xmlns:r="http://schemas.openxmlformats.org/officeDocument/2006/relationships" xmlns:p="http://schemas.openxmlformats.org/presentationml/2006/main">
   <p:cSld>
     <p:spTree>
       <p:nvGrpSpPr>
@@ -3100,7 +3619,14 @@
         <p:cNvGrpSpPr/>
         <p:nvPr/>
       </p:nvGrpSpPr>
-      <p:grpSpPr/>
+      <p:grpSpPr>
+        <a:xfrm>
+          <a:off x="0" y="0"/>
+          <a:ext cx="0" cy="0"/>
+          <a:chOff x="0" y="0"/>
+          <a:chExt cx="0" cy="0"/>
+        </a:xfrm>
+      </p:grpSpPr>
       <p:sp>
         <p:nvSpPr>
           <p:cNvPr id="2" name="Rectangle 1"/>
@@ -3141,6 +3667,7 @@
           <a:lstStyle/>
           <a:p>
             <a:pPr algn="ctr"/>
+            <a:endParaRPr/>
           </a:p>
         </p:txBody>
       </p:sp>
@@ -3184,6 +3711,7 @@
           <a:lstStyle/>
           <a:p>
             <a:pPr algn="ctr"/>
+            <a:endParaRPr/>
           </a:p>
         </p:txBody>
       </p:sp>
@@ -3227,6 +3755,7 @@
           <a:lstStyle/>
           <a:p>
             <a:pPr algn="ctr"/>
+            <a:endParaRPr/>
           </a:p>
         </p:txBody>
       </p:sp>
@@ -3270,6 +3799,7 @@
           <a:lstStyle/>
           <a:p>
             <a:pPr algn="ctr"/>
+            <a:endParaRPr/>
           </a:p>
         </p:txBody>
       </p:sp>
@@ -3313,6 +3843,7 @@
           <a:lstStyle/>
           <a:p>
             <a:pPr algn="ctr"/>
+            <a:endParaRPr/>
           </a:p>
         </p:txBody>
       </p:sp>
@@ -3356,6 +3887,7 @@
           <a:lstStyle/>
           <a:p>
             <a:pPr algn="ctr"/>
+            <a:endParaRPr/>
           </a:p>
         </p:txBody>
       </p:sp>
@@ -3399,6 +3931,7 @@
           <a:lstStyle/>
           <a:p>
             <a:pPr algn="ctr"/>
+            <a:endParaRPr/>
           </a:p>
         </p:txBody>
       </p:sp>
@@ -3442,6 +3975,7 @@
           <a:lstStyle/>
           <a:p>
             <a:pPr algn="ctr"/>
+            <a:endParaRPr/>
           </a:p>
         </p:txBody>
       </p:sp>
@@ -3604,11 +4138,11 @@
           </a:fontRef>
         </p:style>
         <p:txBody>
-          <a:bodyPr rtlCol="0" anchor="ctr" wrap="square" lIns="274320" tIns="228600"/>
+          <a:bodyPr wrap="square" lIns="274320" tIns="228600" rtlCol="0" anchor="ctr"/>
           <a:lstStyle/>
           <a:p>
             <a:pPr algn="ctr">
-              <a:defRPr b="1" sz="1200">
+              <a:defRPr sz="1200" b="1">
                 <a:solidFill>
                   <a:srgbClr val="E11D48"/>
                 </a:solidFill>
@@ -3625,7 +4159,7 @@
               </a:spcBef>
             </a:pPr>
             <a:r>
-              <a:rPr b="1" sz="1000">
+              <a:rPr sz="1000" b="1">
                 <a:solidFill>
                   <a:srgbClr val="1E293B"/>
                 </a:solidFill>
@@ -3648,7 +4182,7 @@
               </a:spcBef>
             </a:pPr>
             <a:r>
-              <a:rPr b="1" sz="1000">
+              <a:rPr sz="1000" b="1">
                 <a:solidFill>
                   <a:srgbClr val="1E293B"/>
                 </a:solidFill>
@@ -3671,7 +4205,7 @@
               </a:spcBef>
             </a:pPr>
             <a:r>
-              <a:rPr b="1" sz="1000">
+              <a:rPr sz="1000" b="1">
                 <a:solidFill>
                   <a:srgbClr val="1E293B"/>
                 </a:solidFill>
@@ -3694,7 +4228,7 @@
               </a:spcBef>
             </a:pPr>
             <a:r>
-              <a:rPr b="1" sz="1000">
+              <a:rPr sz="1000" b="1">
                 <a:solidFill>
                   <a:srgbClr val="1E293B"/>
                 </a:solidFill>
@@ -3717,7 +4251,7 @@
               </a:spcBef>
             </a:pPr>
             <a:r>
-              <a:rPr b="1" sz="1000">
+              <a:rPr sz="1000" b="1">
                 <a:solidFill>
                   <a:srgbClr val="1E293B"/>
                 </a:solidFill>
@@ -3740,7 +4274,7 @@
               </a:spcBef>
             </a:pPr>
             <a:r>
-              <a:rPr b="1" sz="1000">
+              <a:rPr sz="1000" b="1">
                 <a:solidFill>
                   <a:srgbClr val="1E293B"/>
                 </a:solidFill>
@@ -3800,6 +4334,7 @@
           <a:lstStyle/>
           <a:p>
             <a:pPr algn="ctr"/>
+            <a:endParaRPr/>
           </a:p>
         </p:txBody>
       </p:sp>
@@ -3865,11 +4400,11 @@
           </a:fontRef>
         </p:style>
         <p:txBody>
-          <a:bodyPr rtlCol="0" anchor="ctr" wrap="square" lIns="182880" tIns="137160"/>
+          <a:bodyPr wrap="square" lIns="182880" tIns="137160" rtlCol="0" anchor="ctr"/>
           <a:lstStyle/>
           <a:p>
             <a:pPr algn="ctr">
-              <a:defRPr b="1" sz="1100">
+              <a:defRPr sz="1100" b="1">
                 <a:solidFill>
                   <a:srgbClr val="E11D48"/>
                 </a:solidFill>
@@ -3902,7 +4437,7 @@
 </file>
 
 <file path=ppt/slides/slide10.xml><?xml version="1.0" encoding="utf-8"?>
-<p:sld xmlns:a="http://schemas.openxmlformats.org/drawingml/2006/main" xmlns:p="http://schemas.openxmlformats.org/presentationml/2006/main" xmlns:r="http://schemas.openxmlformats.org/officeDocument/2006/relationships">
+<p:sld xmlns:a="http://schemas.openxmlformats.org/drawingml/2006/main" xmlns:r="http://schemas.openxmlformats.org/officeDocument/2006/relationships" xmlns:p="http://schemas.openxmlformats.org/presentationml/2006/main">
   <p:cSld>
     <p:spTree>
       <p:nvGrpSpPr>
@@ -3910,7 +4445,14 @@
         <p:cNvGrpSpPr/>
         <p:nvPr/>
       </p:nvGrpSpPr>
-      <p:grpSpPr/>
+      <p:grpSpPr>
+        <a:xfrm>
+          <a:off x="0" y="0"/>
+          <a:ext cx="0" cy="0"/>
+          <a:chOff x="0" y="0"/>
+          <a:chExt cx="0" cy="0"/>
+        </a:xfrm>
+      </p:grpSpPr>
       <p:sp>
         <p:nvSpPr>
           <p:cNvPr id="2" name="Rectangle 1"/>
@@ -3951,6 +4493,7 @@
           <a:lstStyle/>
           <a:p>
             <a:pPr algn="ctr"/>
+            <a:endParaRPr/>
           </a:p>
         </p:txBody>
       </p:sp>
@@ -3994,6 +4537,7 @@
           <a:lstStyle/>
           <a:p>
             <a:pPr algn="ctr"/>
+            <a:endParaRPr/>
           </a:p>
         </p:txBody>
       </p:sp>
@@ -4037,6 +4581,7 @@
           <a:lstStyle/>
           <a:p>
             <a:pPr algn="ctr"/>
+            <a:endParaRPr/>
           </a:p>
         </p:txBody>
       </p:sp>
@@ -4080,6 +4625,7 @@
           <a:lstStyle/>
           <a:p>
             <a:pPr algn="ctr"/>
+            <a:endParaRPr/>
           </a:p>
         </p:txBody>
       </p:sp>
@@ -4123,6 +4669,7 @@
           <a:lstStyle/>
           <a:p>
             <a:pPr algn="ctr"/>
+            <a:endParaRPr/>
           </a:p>
         </p:txBody>
       </p:sp>
@@ -4166,6 +4713,7 @@
           <a:lstStyle/>
           <a:p>
             <a:pPr algn="ctr"/>
+            <a:endParaRPr/>
           </a:p>
         </p:txBody>
       </p:sp>
@@ -4209,6 +4757,7 @@
           <a:lstStyle/>
           <a:p>
             <a:pPr algn="ctr"/>
+            <a:endParaRPr/>
           </a:p>
         </p:txBody>
       </p:sp>
@@ -4252,6 +4801,7 @@
           <a:lstStyle/>
           <a:p>
             <a:pPr algn="ctr"/>
+            <a:endParaRPr/>
           </a:p>
         </p:txBody>
       </p:sp>
@@ -4293,7 +4843,7 @@
           </a:fontRef>
         </p:style>
         <p:txBody>
-          <a:bodyPr rtlCol="0" anchor="ctr" wrap="none"/>
+          <a:bodyPr wrap="none" rtlCol="0" anchor="ctr"/>
           <a:lstStyle/>
           <a:p>
             <a:pPr algn="ctr">
@@ -4443,6 +4993,7 @@
           <a:lstStyle/>
           <a:p>
             <a:pPr algn="ctr"/>
+            <a:endParaRPr/>
           </a:p>
         </p:txBody>
       </p:sp>
@@ -4508,11 +5059,11 @@
           </a:fontRef>
         </p:style>
         <p:txBody>
-          <a:bodyPr rtlCol="0" anchor="ctr" wrap="square" lIns="228600" tIns="182880"/>
+          <a:bodyPr wrap="square" lIns="228600" tIns="182880" rtlCol="0" anchor="ctr"/>
           <a:lstStyle/>
           <a:p>
             <a:pPr algn="ctr">
-              <a:defRPr b="1" sz="1150">
+              <a:defRPr sz="1150" b="1">
                 <a:solidFill>
                   <a:srgbClr val="E11D48"/>
                 </a:solidFill>
@@ -4529,7 +5080,7 @@
               </a:spcBef>
             </a:pPr>
             <a:r>
-              <a:rPr b="1" sz="950">
+              <a:rPr sz="950" b="1">
                 <a:solidFill>
                   <a:srgbClr val="8B5CF6"/>
                 </a:solidFill>
@@ -4552,7 +5103,7 @@
               </a:spcBef>
             </a:pPr>
             <a:r>
-              <a:rPr b="1" sz="950">
+              <a:rPr sz="950" b="1">
                 <a:solidFill>
                   <a:srgbClr val="8B5CF6"/>
                 </a:solidFill>
@@ -4575,7 +5126,7 @@
               </a:spcBef>
             </a:pPr>
             <a:r>
-              <a:rPr b="1" sz="950">
+              <a:rPr sz="950" b="1">
                 <a:solidFill>
                   <a:srgbClr val="8B5CF6"/>
                 </a:solidFill>
@@ -4598,7 +5149,7 @@
               </a:spcBef>
             </a:pPr>
             <a:r>
-              <a:rPr b="1" sz="950">
+              <a:rPr sz="950" b="1">
                 <a:solidFill>
                   <a:srgbClr val="8B5CF6"/>
                 </a:solidFill>
@@ -4621,7 +5172,7 @@
               </a:spcBef>
             </a:pPr>
             <a:r>
-              <a:rPr b="1" sz="950">
+              <a:rPr sz="950" b="1">
                 <a:solidFill>
                   <a:srgbClr val="8B5CF6"/>
                 </a:solidFill>
@@ -4681,6 +5232,7 @@
           <a:lstStyle/>
           <a:p>
             <a:pPr algn="ctr"/>
+            <a:endParaRPr/>
           </a:p>
         </p:txBody>
       </p:sp>
@@ -4746,7 +5298,7 @@
           </a:fontRef>
         </p:style>
         <p:txBody>
-          <a:bodyPr rtlCol="0" anchor="ctr" wrap="square" lIns="137160" rIns="137160" tIns="109728" bIns="91440"/>
+          <a:bodyPr wrap="square" lIns="137160" tIns="109728" rIns="137160" bIns="91440" rtlCol="0" anchor="ctr"/>
           <a:lstStyle/>
           <a:p>
             <a:pPr algn="ctr">
@@ -4785,7 +5337,7 @@
 </file>
 
 <file path=ppt/slides/slide11.xml><?xml version="1.0" encoding="utf-8"?>
-<p:sld xmlns:a="http://schemas.openxmlformats.org/drawingml/2006/main" xmlns:p="http://schemas.openxmlformats.org/presentationml/2006/main" xmlns:r="http://schemas.openxmlformats.org/officeDocument/2006/relationships">
+<p:sld xmlns:a="http://schemas.openxmlformats.org/drawingml/2006/main" xmlns:r="http://schemas.openxmlformats.org/officeDocument/2006/relationships" xmlns:p="http://schemas.openxmlformats.org/presentationml/2006/main">
   <p:cSld>
     <p:spTree>
       <p:nvGrpSpPr>
@@ -4793,7 +5345,14 @@
         <p:cNvGrpSpPr/>
         <p:nvPr/>
       </p:nvGrpSpPr>
-      <p:grpSpPr/>
+      <p:grpSpPr>
+        <a:xfrm>
+          <a:off x="0" y="0"/>
+          <a:ext cx="0" cy="0"/>
+          <a:chOff x="0" y="0"/>
+          <a:chExt cx="0" cy="0"/>
+        </a:xfrm>
+      </p:grpSpPr>
       <p:sp>
         <p:nvSpPr>
           <p:cNvPr id="2" name="Rectangle 1"/>
@@ -4834,6 +5393,7 @@
           <a:lstStyle/>
           <a:p>
             <a:pPr algn="ctr"/>
+            <a:endParaRPr/>
           </a:p>
         </p:txBody>
       </p:sp>
@@ -4877,6 +5437,7 @@
           <a:lstStyle/>
           <a:p>
             <a:pPr algn="ctr"/>
+            <a:endParaRPr/>
           </a:p>
         </p:txBody>
       </p:sp>
@@ -4920,6 +5481,7 @@
           <a:lstStyle/>
           <a:p>
             <a:pPr algn="ctr"/>
+            <a:endParaRPr/>
           </a:p>
         </p:txBody>
       </p:sp>
@@ -4963,6 +5525,7 @@
           <a:lstStyle/>
           <a:p>
             <a:pPr algn="ctr"/>
+            <a:endParaRPr/>
           </a:p>
         </p:txBody>
       </p:sp>
@@ -5006,6 +5569,7 @@
           <a:lstStyle/>
           <a:p>
             <a:pPr algn="ctr"/>
+            <a:endParaRPr/>
           </a:p>
         </p:txBody>
       </p:sp>
@@ -5049,6 +5613,7 @@
           <a:lstStyle/>
           <a:p>
             <a:pPr algn="ctr"/>
+            <a:endParaRPr/>
           </a:p>
         </p:txBody>
       </p:sp>
@@ -5092,6 +5657,7 @@
           <a:lstStyle/>
           <a:p>
             <a:pPr algn="ctr"/>
+            <a:endParaRPr/>
           </a:p>
         </p:txBody>
       </p:sp>
@@ -5135,6 +5701,7 @@
           <a:lstStyle/>
           <a:p>
             <a:pPr algn="ctr"/>
+            <a:endParaRPr/>
           </a:p>
         </p:txBody>
       </p:sp>
@@ -5176,7 +5743,7 @@
           </a:fontRef>
         </p:style>
         <p:txBody>
-          <a:bodyPr rtlCol="0" anchor="ctr" wrap="none"/>
+          <a:bodyPr wrap="none" rtlCol="0" anchor="ctr"/>
           <a:lstStyle/>
           <a:p>
             <a:pPr algn="ctr">
@@ -5322,11 +5889,11 @@
           </a:fontRef>
         </p:style>
         <p:txBody>
-          <a:bodyPr rtlCol="0" anchor="ctr" wrap="square" tIns="164592"/>
+          <a:bodyPr wrap="square" tIns="164592" rtlCol="0" anchor="ctr"/>
           <a:lstStyle/>
           <a:p>
             <a:pPr algn="ctr">
-              <a:defRPr b="1" sz="2800">
+              <a:defRPr sz="2800" b="1">
                 <a:solidFill>
                   <a:srgbClr val="E11D48"/>
                 </a:solidFill>
@@ -5338,7 +5905,7 @@
           </a:p>
           <a:p>
             <a:pPr algn="ctr">
-              <a:defRPr b="1" sz="1000">
+              <a:defRPr sz="1000" b="1">
                 <a:solidFill>
                   <a:srgbClr val="1E293B"/>
                 </a:solidFill>
@@ -5400,11 +5967,11 @@
           </a:fontRef>
         </p:style>
         <p:txBody>
-          <a:bodyPr rtlCol="0" anchor="ctr" wrap="square" tIns="164592"/>
+          <a:bodyPr wrap="square" tIns="164592" rtlCol="0" anchor="ctr"/>
           <a:lstStyle/>
           <a:p>
             <a:pPr algn="ctr">
-              <a:defRPr b="1" sz="2800">
+              <a:defRPr sz="2800" b="1">
                 <a:solidFill>
                   <a:srgbClr val="FF5C8A"/>
                 </a:solidFill>
@@ -5416,7 +5983,7 @@
           </a:p>
           <a:p>
             <a:pPr algn="ctr">
-              <a:defRPr b="1" sz="1000">
+              <a:defRPr sz="1000" b="1">
                 <a:solidFill>
                   <a:srgbClr val="1E293B"/>
                 </a:solidFill>
@@ -5478,11 +6045,11 @@
           </a:fontRef>
         </p:style>
         <p:txBody>
-          <a:bodyPr rtlCol="0" anchor="ctr" wrap="square" tIns="164592"/>
+          <a:bodyPr wrap="square" tIns="164592" rtlCol="0" anchor="ctr"/>
           <a:lstStyle/>
           <a:p>
             <a:pPr algn="ctr">
-              <a:defRPr b="1" sz="2800">
+              <a:defRPr sz="2800" b="1">
                 <a:solidFill>
                   <a:srgbClr val="10B981"/>
                 </a:solidFill>
@@ -5494,7 +6061,7 @@
           </a:p>
           <a:p>
             <a:pPr algn="ctr">
-              <a:defRPr b="1" sz="1000">
+              <a:defRPr sz="1000" b="1">
                 <a:solidFill>
                   <a:srgbClr val="1E293B"/>
                 </a:solidFill>
@@ -5556,11 +6123,11 @@
           </a:fontRef>
         </p:style>
         <p:txBody>
-          <a:bodyPr rtlCol="0" anchor="ctr" wrap="square" tIns="164592"/>
+          <a:bodyPr wrap="square" tIns="164592" rtlCol="0" anchor="ctr"/>
           <a:lstStyle/>
           <a:p>
             <a:pPr algn="ctr">
-              <a:defRPr b="1" sz="2800">
+              <a:defRPr sz="2800" b="1">
                 <a:solidFill>
                   <a:srgbClr val="F59E0B"/>
                 </a:solidFill>
@@ -5572,7 +6139,7 @@
           </a:p>
           <a:p>
             <a:pPr algn="ctr">
-              <a:defRPr b="1" sz="1000">
+              <a:defRPr sz="1000" b="1">
                 <a:solidFill>
                   <a:srgbClr val="1E293B"/>
                 </a:solidFill>
@@ -5634,11 +6201,11 @@
           </a:fontRef>
         </p:style>
         <p:txBody>
-          <a:bodyPr rtlCol="0" anchor="ctr" wrap="square" lIns="228600" tIns="164592"/>
+          <a:bodyPr wrap="square" lIns="228600" tIns="164592" rtlCol="0" anchor="ctr"/>
           <a:lstStyle/>
           <a:p>
             <a:pPr algn="ctr">
-              <a:defRPr b="1" sz="1150">
+              <a:defRPr sz="1150" b="1">
                 <a:solidFill>
                   <a:srgbClr val="E11D48"/>
                 </a:solidFill>
@@ -5655,7 +6222,7 @@
               </a:spcBef>
             </a:pPr>
             <a:r>
-              <a:rPr b="1" sz="950">
+              <a:rPr sz="950" b="1">
                 <a:solidFill>
                   <a:srgbClr val="1E293B"/>
                 </a:solidFill>
@@ -5678,7 +6245,7 @@
               </a:spcBef>
             </a:pPr>
             <a:r>
-              <a:rPr b="1" sz="950">
+              <a:rPr sz="950" b="1">
                 <a:solidFill>
                   <a:srgbClr val="1E293B"/>
                 </a:solidFill>
@@ -5701,7 +6268,7 @@
               </a:spcBef>
             </a:pPr>
             <a:r>
-              <a:rPr b="1" sz="950">
+              <a:rPr sz="950" b="1">
                 <a:solidFill>
                   <a:srgbClr val="1E293B"/>
                 </a:solidFill>
@@ -5724,7 +6291,7 @@
               </a:spcBef>
             </a:pPr>
             <a:r>
-              <a:rPr b="1" sz="950">
+              <a:rPr sz="950" b="1">
                 <a:solidFill>
                   <a:srgbClr val="1E293B"/>
                 </a:solidFill>
@@ -5784,6 +6351,7 @@
           <a:lstStyle/>
           <a:p>
             <a:pPr algn="ctr"/>
+            <a:endParaRPr/>
           </a:p>
         </p:txBody>
       </p:sp>
@@ -5849,7 +6417,7 @@
           </a:fontRef>
         </p:style>
         <p:txBody>
-          <a:bodyPr rtlCol="0" anchor="ctr" wrap="square" lIns="137160" rIns="137160" tIns="109728" bIns="91440"/>
+          <a:bodyPr wrap="square" lIns="137160" tIns="109728" rIns="137160" bIns="91440" rtlCol="0" anchor="ctr"/>
           <a:lstStyle/>
           <a:p>
             <a:pPr algn="ctr">
@@ -5888,7 +6456,7 @@
 </file>
 
 <file path=ppt/slides/slide12.xml><?xml version="1.0" encoding="utf-8"?>
-<p:sld xmlns:a="http://schemas.openxmlformats.org/drawingml/2006/main" xmlns:p="http://schemas.openxmlformats.org/presentationml/2006/main" xmlns:r="http://schemas.openxmlformats.org/officeDocument/2006/relationships">
+<p:sld xmlns:a="http://schemas.openxmlformats.org/drawingml/2006/main" xmlns:r="http://schemas.openxmlformats.org/officeDocument/2006/relationships" xmlns:p="http://schemas.openxmlformats.org/presentationml/2006/main">
   <p:cSld>
     <p:spTree>
       <p:nvGrpSpPr>
@@ -5896,7 +6464,14 @@
         <p:cNvGrpSpPr/>
         <p:nvPr/>
       </p:nvGrpSpPr>
-      <p:grpSpPr/>
+      <p:grpSpPr>
+        <a:xfrm>
+          <a:off x="0" y="0"/>
+          <a:ext cx="0" cy="0"/>
+          <a:chOff x="0" y="0"/>
+          <a:chExt cx="0" cy="0"/>
+        </a:xfrm>
+      </p:grpSpPr>
       <p:sp>
         <p:nvSpPr>
           <p:cNvPr id="2" name="Rectangle 1"/>
@@ -5937,6 +6512,7 @@
           <a:lstStyle/>
           <a:p>
             <a:pPr algn="ctr"/>
+            <a:endParaRPr/>
           </a:p>
         </p:txBody>
       </p:sp>
@@ -5980,6 +6556,7 @@
           <a:lstStyle/>
           <a:p>
             <a:pPr algn="ctr"/>
+            <a:endParaRPr/>
           </a:p>
         </p:txBody>
       </p:sp>
@@ -6023,6 +6600,7 @@
           <a:lstStyle/>
           <a:p>
             <a:pPr algn="ctr"/>
+            <a:endParaRPr/>
           </a:p>
         </p:txBody>
       </p:sp>
@@ -6066,6 +6644,7 @@
           <a:lstStyle/>
           <a:p>
             <a:pPr algn="ctr"/>
+            <a:endParaRPr/>
           </a:p>
         </p:txBody>
       </p:sp>
@@ -6109,6 +6688,7 @@
           <a:lstStyle/>
           <a:p>
             <a:pPr algn="ctr"/>
+            <a:endParaRPr/>
           </a:p>
         </p:txBody>
       </p:sp>
@@ -6152,6 +6732,7 @@
           <a:lstStyle/>
           <a:p>
             <a:pPr algn="ctr"/>
+            <a:endParaRPr/>
           </a:p>
         </p:txBody>
       </p:sp>
@@ -6195,6 +6776,7 @@
           <a:lstStyle/>
           <a:p>
             <a:pPr algn="ctr"/>
+            <a:endParaRPr/>
           </a:p>
         </p:txBody>
       </p:sp>
@@ -6238,6 +6820,7 @@
           <a:lstStyle/>
           <a:p>
             <a:pPr algn="ctr"/>
+            <a:endParaRPr/>
           </a:p>
         </p:txBody>
       </p:sp>
@@ -6279,7 +6862,7 @@
           </a:fontRef>
         </p:style>
         <p:txBody>
-          <a:bodyPr rtlCol="0" anchor="ctr" wrap="none"/>
+          <a:bodyPr wrap="none" rtlCol="0" anchor="ctr"/>
           <a:lstStyle/>
           <a:p>
             <a:pPr algn="ctr">
@@ -6425,11 +7008,11 @@
           </a:fontRef>
         </p:style>
         <p:txBody>
-          <a:bodyPr rtlCol="0" anchor="ctr" wrap="square" lIns="182880" rIns="182880" tIns="182880"/>
+          <a:bodyPr wrap="square" lIns="182880" tIns="182880" rIns="182880" rtlCol="0" anchor="ctr"/>
           <a:lstStyle/>
           <a:p>
             <a:pPr algn="ctr">
-              <a:defRPr b="1" sz="1100">
+              <a:defRPr sz="1100" b="1">
                 <a:solidFill>
                   <a:srgbClr val="10B981"/>
                 </a:solidFill>
@@ -6566,11 +7149,11 @@
           </a:fontRef>
         </p:style>
         <p:txBody>
-          <a:bodyPr rtlCol="0" anchor="ctr" wrap="square" lIns="182880" rIns="182880" tIns="182880"/>
+          <a:bodyPr wrap="square" lIns="182880" tIns="182880" rIns="182880" rtlCol="0" anchor="ctr"/>
           <a:lstStyle/>
           <a:p>
             <a:pPr algn="ctr">
-              <a:defRPr b="1" sz="1100">
+              <a:defRPr sz="1100" b="1">
                 <a:solidFill>
                   <a:srgbClr val="F59E0B"/>
                 </a:solidFill>
@@ -6692,11 +7275,11 @@
           </a:fontRef>
         </p:style>
         <p:txBody>
-          <a:bodyPr rtlCol="0" anchor="ctr" wrap="square" lIns="182880" rIns="182880" tIns="182880"/>
+          <a:bodyPr wrap="square" lIns="182880" tIns="182880" rIns="182880" rtlCol="0" anchor="ctr"/>
           <a:lstStyle/>
           <a:p>
             <a:pPr algn="ctr">
-              <a:defRPr b="1" sz="1100">
+              <a:defRPr sz="1100" b="1">
                 <a:solidFill>
                   <a:srgbClr val="E11D48"/>
                 </a:solidFill>
@@ -6822,6 +7405,7 @@
           <a:lstStyle/>
           <a:p>
             <a:pPr algn="ctr"/>
+            <a:endParaRPr/>
           </a:p>
         </p:txBody>
       </p:sp>
@@ -6887,7 +7471,7 @@
           </a:fontRef>
         </p:style>
         <p:txBody>
-          <a:bodyPr rtlCol="0" anchor="ctr" wrap="square" lIns="137160" rIns="137160" tIns="109728" bIns="91440"/>
+          <a:bodyPr wrap="square" lIns="137160" tIns="109728" rIns="137160" bIns="91440" rtlCol="0" anchor="ctr"/>
           <a:lstStyle/>
           <a:p>
             <a:pPr algn="ctr">
@@ -6926,7 +7510,7 @@
 </file>
 
 <file path=ppt/slides/slide13.xml><?xml version="1.0" encoding="utf-8"?>
-<p:sld xmlns:a="http://schemas.openxmlformats.org/drawingml/2006/main" xmlns:p="http://schemas.openxmlformats.org/presentationml/2006/main" xmlns:r="http://schemas.openxmlformats.org/officeDocument/2006/relationships">
+<p:sld xmlns:a="http://schemas.openxmlformats.org/drawingml/2006/main" xmlns:r="http://schemas.openxmlformats.org/officeDocument/2006/relationships" xmlns:p="http://schemas.openxmlformats.org/presentationml/2006/main">
   <p:cSld>
     <p:spTree>
       <p:nvGrpSpPr>
@@ -6934,7 +7518,14 @@
         <p:cNvGrpSpPr/>
         <p:nvPr/>
       </p:nvGrpSpPr>
-      <p:grpSpPr/>
+      <p:grpSpPr>
+        <a:xfrm>
+          <a:off x="0" y="0"/>
+          <a:ext cx="0" cy="0"/>
+          <a:chOff x="0" y="0"/>
+          <a:chExt cx="0" cy="0"/>
+        </a:xfrm>
+      </p:grpSpPr>
       <p:sp>
         <p:nvSpPr>
           <p:cNvPr id="2" name="Rectangle 1"/>
@@ -6975,6 +7566,7 @@
           <a:lstStyle/>
           <a:p>
             <a:pPr algn="ctr"/>
+            <a:endParaRPr/>
           </a:p>
         </p:txBody>
       </p:sp>
@@ -7018,6 +7610,7 @@
           <a:lstStyle/>
           <a:p>
             <a:pPr algn="ctr"/>
+            <a:endParaRPr/>
           </a:p>
         </p:txBody>
       </p:sp>
@@ -7061,6 +7654,7 @@
           <a:lstStyle/>
           <a:p>
             <a:pPr algn="ctr"/>
+            <a:endParaRPr/>
           </a:p>
         </p:txBody>
       </p:sp>
@@ -7104,6 +7698,7 @@
           <a:lstStyle/>
           <a:p>
             <a:pPr algn="ctr"/>
+            <a:endParaRPr/>
           </a:p>
         </p:txBody>
       </p:sp>
@@ -7147,6 +7742,7 @@
           <a:lstStyle/>
           <a:p>
             <a:pPr algn="ctr"/>
+            <a:endParaRPr/>
           </a:p>
         </p:txBody>
       </p:sp>
@@ -7190,6 +7786,7 @@
           <a:lstStyle/>
           <a:p>
             <a:pPr algn="ctr"/>
+            <a:endParaRPr/>
           </a:p>
         </p:txBody>
       </p:sp>
@@ -7233,6 +7830,7 @@
           <a:lstStyle/>
           <a:p>
             <a:pPr algn="ctr"/>
+            <a:endParaRPr/>
           </a:p>
         </p:txBody>
       </p:sp>
@@ -7276,6 +7874,7 @@
           <a:lstStyle/>
           <a:p>
             <a:pPr algn="ctr"/>
+            <a:endParaRPr/>
           </a:p>
         </p:txBody>
       </p:sp>
@@ -7317,7 +7916,7 @@
           </a:fontRef>
         </p:style>
         <p:txBody>
-          <a:bodyPr rtlCol="0" anchor="ctr" wrap="none"/>
+          <a:bodyPr wrap="none" rtlCol="0" anchor="ctr"/>
           <a:lstStyle/>
           <a:p>
             <a:pPr algn="ctr">
@@ -7463,11 +8062,11 @@
           </a:fontRef>
         </p:style>
         <p:txBody>
-          <a:bodyPr rtlCol="0" anchor="ctr" wrap="square" lIns="164592" rIns="164592" tIns="182880"/>
+          <a:bodyPr wrap="square" lIns="164592" tIns="182880" rIns="164592" rtlCol="0" anchor="ctr"/>
           <a:lstStyle/>
           <a:p>
             <a:pPr algn="ctr">
-              <a:defRPr b="1" sz="1000">
+              <a:defRPr sz="1000" b="1">
                 <a:solidFill>
                   <a:srgbClr val="E11D48"/>
                 </a:solidFill>
@@ -7601,11 +8200,11 @@
           </a:fontRef>
         </p:style>
         <p:txBody>
-          <a:bodyPr rtlCol="0" anchor="ctr" wrap="square" lIns="164592" rIns="164592" tIns="182880"/>
+          <a:bodyPr wrap="square" lIns="164592" tIns="182880" rIns="164592" rtlCol="0" anchor="ctr"/>
           <a:lstStyle/>
           <a:p>
             <a:pPr algn="ctr">
-              <a:defRPr b="1" sz="1000">
+              <a:defRPr sz="1000" b="1">
                 <a:solidFill>
                   <a:srgbClr val="F59E0B"/>
                 </a:solidFill>
@@ -7739,11 +8338,11 @@
           </a:fontRef>
         </p:style>
         <p:txBody>
-          <a:bodyPr rtlCol="0" anchor="ctr" wrap="square" lIns="164592" rIns="164592" tIns="182880"/>
+          <a:bodyPr wrap="square" lIns="164592" tIns="182880" rIns="164592" rtlCol="0" anchor="ctr"/>
           <a:lstStyle/>
           <a:p>
             <a:pPr algn="ctr">
-              <a:defRPr b="1" sz="1000">
+              <a:defRPr sz="1000" b="1">
                 <a:solidFill>
                   <a:srgbClr val="8B5CF6"/>
                 </a:solidFill>
@@ -7877,11 +8476,11 @@
           </a:fontRef>
         </p:style>
         <p:txBody>
-          <a:bodyPr rtlCol="0" anchor="ctr" wrap="square" lIns="164592" rIns="164592" tIns="182880"/>
+          <a:bodyPr wrap="square" lIns="164592" tIns="182880" rIns="164592" rtlCol="0" anchor="ctr"/>
           <a:lstStyle/>
           <a:p>
             <a:pPr algn="ctr">
-              <a:defRPr b="1" sz="1000">
+              <a:defRPr sz="1000" b="1">
                 <a:solidFill>
                   <a:srgbClr val="10B981"/>
                 </a:solidFill>
@@ -8019,6 +8618,7 @@
           <a:lstStyle/>
           <a:p>
             <a:pPr algn="ctr"/>
+            <a:endParaRPr/>
           </a:p>
         </p:txBody>
       </p:sp>
@@ -8084,7 +8684,7 @@
           </a:fontRef>
         </p:style>
         <p:txBody>
-          <a:bodyPr rtlCol="0" anchor="ctr" wrap="square" lIns="137160" rIns="137160" tIns="109728" bIns="91440"/>
+          <a:bodyPr wrap="square" lIns="137160" tIns="109728" rIns="137160" bIns="91440" rtlCol="0" anchor="ctr"/>
           <a:lstStyle/>
           <a:p>
             <a:pPr algn="ctr">
@@ -8123,7 +8723,7 @@
 </file>
 
 <file path=ppt/slides/slide14.xml><?xml version="1.0" encoding="utf-8"?>
-<p:sld xmlns:a="http://schemas.openxmlformats.org/drawingml/2006/main" xmlns:p="http://schemas.openxmlformats.org/presentationml/2006/main" xmlns:r="http://schemas.openxmlformats.org/officeDocument/2006/relationships">
+<p:sld xmlns:a="http://schemas.openxmlformats.org/drawingml/2006/main" xmlns:r="http://schemas.openxmlformats.org/officeDocument/2006/relationships" xmlns:p="http://schemas.openxmlformats.org/presentationml/2006/main">
   <p:cSld>
     <p:spTree>
       <p:nvGrpSpPr>
@@ -8131,7 +8731,14 @@
         <p:cNvGrpSpPr/>
         <p:nvPr/>
       </p:nvGrpSpPr>
-      <p:grpSpPr/>
+      <p:grpSpPr>
+        <a:xfrm>
+          <a:off x="0" y="0"/>
+          <a:ext cx="0" cy="0"/>
+          <a:chOff x="0" y="0"/>
+          <a:chExt cx="0" cy="0"/>
+        </a:xfrm>
+      </p:grpSpPr>
       <p:sp>
         <p:nvSpPr>
           <p:cNvPr id="2" name="Rectangle 1"/>
@@ -8172,6 +8779,7 @@
           <a:lstStyle/>
           <a:p>
             <a:pPr algn="ctr"/>
+            <a:endParaRPr/>
           </a:p>
         </p:txBody>
       </p:sp>
@@ -8215,6 +8823,7 @@
           <a:lstStyle/>
           <a:p>
             <a:pPr algn="ctr"/>
+            <a:endParaRPr/>
           </a:p>
         </p:txBody>
       </p:sp>
@@ -8258,6 +8867,7 @@
           <a:lstStyle/>
           <a:p>
             <a:pPr algn="ctr"/>
+            <a:endParaRPr/>
           </a:p>
         </p:txBody>
       </p:sp>
@@ -8301,6 +8911,7 @@
           <a:lstStyle/>
           <a:p>
             <a:pPr algn="ctr"/>
+            <a:endParaRPr/>
           </a:p>
         </p:txBody>
       </p:sp>
@@ -8344,6 +8955,7 @@
           <a:lstStyle/>
           <a:p>
             <a:pPr algn="ctr"/>
+            <a:endParaRPr/>
           </a:p>
         </p:txBody>
       </p:sp>
@@ -8387,6 +8999,7 @@
           <a:lstStyle/>
           <a:p>
             <a:pPr algn="ctr"/>
+            <a:endParaRPr/>
           </a:p>
         </p:txBody>
       </p:sp>
@@ -8430,6 +9043,7 @@
           <a:lstStyle/>
           <a:p>
             <a:pPr algn="ctr"/>
+            <a:endParaRPr/>
           </a:p>
         </p:txBody>
       </p:sp>
@@ -8473,6 +9087,7 @@
           <a:lstStyle/>
           <a:p>
             <a:pPr algn="ctr"/>
+            <a:endParaRPr/>
           </a:p>
         </p:txBody>
       </p:sp>
@@ -8514,11 +9129,11 @@
           </a:fontRef>
         </p:style>
         <p:txBody>
-          <a:bodyPr rtlCol="0" anchor="ctr" wrap="square" lIns="320040" tIns="320040"/>
+          <a:bodyPr wrap="square" lIns="320040" tIns="320040" rtlCol="0" anchor="ctr"/>
           <a:lstStyle/>
           <a:p>
             <a:pPr algn="ctr">
-              <a:defRPr b="1" sz="1400">
+              <a:defRPr sz="1400" b="1">
                 <a:solidFill>
                   <a:srgbClr val="E11D48"/>
                 </a:solidFill>
@@ -8533,7 +9148,7 @@
               <a:spcBef>
                 <a:spcPts val="800"/>
               </a:spcBef>
-              <a:defRPr b="1" sz="2200">
+              <a:defRPr sz="2200" b="1">
                 <a:solidFill>
                   <a:srgbClr val="1E293B"/>
                 </a:solidFill>
@@ -8550,7 +9165,7 @@
               </a:spcBef>
             </a:pPr>
             <a:r>
-              <a:rPr b="1" sz="1050">
+              <a:rPr sz="1050" b="1">
                 <a:solidFill>
                   <a:srgbClr val="FF5C8A"/>
                 </a:solidFill>
@@ -8573,7 +9188,7 @@
               </a:spcBef>
             </a:pPr>
             <a:r>
-              <a:rPr b="1" sz="1050">
+              <a:rPr sz="1050" b="1">
                 <a:solidFill>
                   <a:srgbClr val="FF5C8A"/>
                 </a:solidFill>
@@ -8596,7 +9211,7 @@
               </a:spcBef>
             </a:pPr>
             <a:r>
-              <a:rPr b="1" sz="1050">
+              <a:rPr sz="1050" b="1">
                 <a:solidFill>
                   <a:srgbClr val="FF5C8A"/>
                 </a:solidFill>
@@ -8619,7 +9234,7 @@
               </a:spcBef>
             </a:pPr>
             <a:r>
-              <a:rPr b="1" sz="1050">
+              <a:rPr sz="1050" b="1">
                 <a:solidFill>
                   <a:srgbClr val="FF5C8A"/>
                 </a:solidFill>
@@ -8679,6 +9294,7 @@
           <a:lstStyle/>
           <a:p>
             <a:pPr algn="ctr"/>
+            <a:endParaRPr/>
           </a:p>
         </p:txBody>
       </p:sp>
@@ -8744,11 +9360,11 @@
           </a:fontRef>
         </p:style>
         <p:txBody>
-          <a:bodyPr rtlCol="0" anchor="ctr" wrap="square" lIns="137160" tIns="109728"/>
+          <a:bodyPr wrap="square" lIns="137160" tIns="109728" rtlCol="0" anchor="ctr"/>
           <a:lstStyle/>
           <a:p>
             <a:pPr algn="ctr">
-              <a:defRPr b="1" sz="1050">
+              <a:defRPr sz="1050" b="1">
                 <a:solidFill>
                   <a:srgbClr val="E11D48"/>
                 </a:solidFill>
@@ -8781,7 +9397,7 @@
 </file>
 
 <file path=ppt/slides/slide2.xml><?xml version="1.0" encoding="utf-8"?>
-<p:sld xmlns:a="http://schemas.openxmlformats.org/drawingml/2006/main" xmlns:p="http://schemas.openxmlformats.org/presentationml/2006/main" xmlns:r="http://schemas.openxmlformats.org/officeDocument/2006/relationships">
+<p:sld xmlns:a="http://schemas.openxmlformats.org/drawingml/2006/main" xmlns:r="http://schemas.openxmlformats.org/officeDocument/2006/relationships" xmlns:p="http://schemas.openxmlformats.org/presentationml/2006/main">
   <p:cSld>
     <p:spTree>
       <p:nvGrpSpPr>
@@ -8789,7 +9405,14 @@
         <p:cNvGrpSpPr/>
         <p:nvPr/>
       </p:nvGrpSpPr>
-      <p:grpSpPr/>
+      <p:grpSpPr>
+        <a:xfrm>
+          <a:off x="0" y="0"/>
+          <a:ext cx="0" cy="0"/>
+          <a:chOff x="0" y="0"/>
+          <a:chExt cx="0" cy="0"/>
+        </a:xfrm>
+      </p:grpSpPr>
       <p:sp>
         <p:nvSpPr>
           <p:cNvPr id="2" name="Rectangle 1"/>
@@ -8830,6 +9453,7 @@
           <a:lstStyle/>
           <a:p>
             <a:pPr algn="ctr"/>
+            <a:endParaRPr/>
           </a:p>
         </p:txBody>
       </p:sp>
@@ -8873,6 +9497,7 @@
           <a:lstStyle/>
           <a:p>
             <a:pPr algn="ctr"/>
+            <a:endParaRPr/>
           </a:p>
         </p:txBody>
       </p:sp>
@@ -8916,6 +9541,7 @@
           <a:lstStyle/>
           <a:p>
             <a:pPr algn="ctr"/>
+            <a:endParaRPr/>
           </a:p>
         </p:txBody>
       </p:sp>
@@ -8959,6 +9585,7 @@
           <a:lstStyle/>
           <a:p>
             <a:pPr algn="ctr"/>
+            <a:endParaRPr/>
           </a:p>
         </p:txBody>
       </p:sp>
@@ -9002,6 +9629,7 @@
           <a:lstStyle/>
           <a:p>
             <a:pPr algn="ctr"/>
+            <a:endParaRPr/>
           </a:p>
         </p:txBody>
       </p:sp>
@@ -9045,6 +9673,7 @@
           <a:lstStyle/>
           <a:p>
             <a:pPr algn="ctr"/>
+            <a:endParaRPr/>
           </a:p>
         </p:txBody>
       </p:sp>
@@ -9088,6 +9717,7 @@
           <a:lstStyle/>
           <a:p>
             <a:pPr algn="ctr"/>
+            <a:endParaRPr/>
           </a:p>
         </p:txBody>
       </p:sp>
@@ -9131,6 +9761,7 @@
           <a:lstStyle/>
           <a:p>
             <a:pPr algn="ctr"/>
+            <a:endParaRPr/>
           </a:p>
         </p:txBody>
       </p:sp>
@@ -9172,7 +9803,7 @@
           </a:fontRef>
         </p:style>
         <p:txBody>
-          <a:bodyPr rtlCol="0" anchor="ctr" wrap="none"/>
+          <a:bodyPr wrap="none" rtlCol="0" anchor="ctr"/>
           <a:lstStyle/>
           <a:p>
             <a:pPr algn="ctr">
@@ -9318,11 +9949,11 @@
           </a:fontRef>
         </p:style>
         <p:txBody>
-          <a:bodyPr rtlCol="0" anchor="ctr" wrap="square" lIns="201168" rIns="182880" tIns="201168"/>
+          <a:bodyPr wrap="square" lIns="201168" tIns="201168" rIns="182880" rtlCol="0" anchor="ctr"/>
           <a:lstStyle/>
           <a:p>
             <a:pPr algn="ctr">
-              <a:defRPr b="1" sz="1300">
+              <a:defRPr sz="1300" b="1">
                 <a:solidFill>
                   <a:srgbClr val="1E293B"/>
                 </a:solidFill>
@@ -9335,7 +9966,7 @@
           </a:p>
           <a:p>
             <a:pPr>
-              <a:defRPr b="1" sz="1050">
+              <a:defRPr sz="1050" b="1">
                 <a:solidFill>
                   <a:srgbClr val="E11D48"/>
                 </a:solidFill>
@@ -9347,7 +9978,7 @@
           </a:p>
           <a:p>
             <a:pPr>
-              <a:defRPr i="1" sz="950">
+              <a:defRPr sz="950" i="1">
                 <a:solidFill>
                   <a:srgbClr val="64748B"/>
                 </a:solidFill>
@@ -9469,11 +10100,11 @@
           </a:fontRef>
         </p:style>
         <p:txBody>
-          <a:bodyPr rtlCol="0" anchor="ctr" wrap="square" lIns="201168" rIns="182880" tIns="201168"/>
+          <a:bodyPr wrap="square" lIns="201168" tIns="201168" rIns="182880" rtlCol="0" anchor="ctr"/>
           <a:lstStyle/>
           <a:p>
             <a:pPr algn="ctr">
-              <a:defRPr b="1" sz="1300">
+              <a:defRPr sz="1300" b="1">
                 <a:solidFill>
                   <a:srgbClr val="1E293B"/>
                 </a:solidFill>
@@ -9486,7 +10117,7 @@
           </a:p>
           <a:p>
             <a:pPr>
-              <a:defRPr b="1" sz="1050">
+              <a:defRPr sz="1050" b="1">
                 <a:solidFill>
                   <a:srgbClr val="E11D48"/>
                 </a:solidFill>
@@ -9498,7 +10129,7 @@
           </a:p>
           <a:p>
             <a:pPr>
-              <a:defRPr i="1" sz="950">
+              <a:defRPr sz="950" i="1">
                 <a:solidFill>
                   <a:srgbClr val="64748B"/>
                 </a:solidFill>
@@ -9620,11 +10251,11 @@
           </a:fontRef>
         </p:style>
         <p:txBody>
-          <a:bodyPr rtlCol="0" anchor="ctr" wrap="square" lIns="201168" rIns="182880" tIns="201168"/>
+          <a:bodyPr wrap="square" lIns="201168" tIns="201168" rIns="182880" rtlCol="0" anchor="ctr"/>
           <a:lstStyle/>
           <a:p>
             <a:pPr algn="ctr">
-              <a:defRPr b="1" sz="1300">
+              <a:defRPr sz="1300" b="1">
                 <a:solidFill>
                   <a:srgbClr val="1E293B"/>
                 </a:solidFill>
@@ -9637,7 +10268,7 @@
           </a:p>
           <a:p>
             <a:pPr>
-              <a:defRPr b="1" sz="1050">
+              <a:defRPr sz="1050" b="1">
                 <a:solidFill>
                   <a:srgbClr val="E11D48"/>
                 </a:solidFill>
@@ -9649,7 +10280,7 @@
           </a:p>
           <a:p>
             <a:pPr>
-              <a:defRPr i="1" sz="950">
+              <a:defRPr sz="950" i="1">
                 <a:solidFill>
                   <a:srgbClr val="64748B"/>
                 </a:solidFill>
@@ -9775,6 +10406,7 @@
           <a:lstStyle/>
           <a:p>
             <a:pPr algn="ctr"/>
+            <a:endParaRPr/>
           </a:p>
         </p:txBody>
       </p:sp>
@@ -9840,7 +10472,7 @@
           </a:fontRef>
         </p:style>
         <p:txBody>
-          <a:bodyPr rtlCol="0" anchor="ctr" wrap="square" lIns="137160" rIns="137160" tIns="109728" bIns="91440"/>
+          <a:bodyPr wrap="square" lIns="137160" tIns="109728" rIns="137160" bIns="91440" rtlCol="0" anchor="ctr"/>
           <a:lstStyle/>
           <a:p>
             <a:pPr algn="ctr">
@@ -9879,7 +10511,7 @@
 </file>
 
 <file path=ppt/slides/slide3.xml><?xml version="1.0" encoding="utf-8"?>
-<p:sld xmlns:a="http://schemas.openxmlformats.org/drawingml/2006/main" xmlns:p="http://schemas.openxmlformats.org/presentationml/2006/main" xmlns:r="http://schemas.openxmlformats.org/officeDocument/2006/relationships">
+<p:sld xmlns:a="http://schemas.openxmlformats.org/drawingml/2006/main" xmlns:r="http://schemas.openxmlformats.org/officeDocument/2006/relationships" xmlns:p="http://schemas.openxmlformats.org/presentationml/2006/main">
   <p:cSld>
     <p:spTree>
       <p:nvGrpSpPr>
@@ -9887,7 +10519,14 @@
         <p:cNvGrpSpPr/>
         <p:nvPr/>
       </p:nvGrpSpPr>
-      <p:grpSpPr/>
+      <p:grpSpPr>
+        <a:xfrm>
+          <a:off x="0" y="0"/>
+          <a:ext cx="0" cy="0"/>
+          <a:chOff x="0" y="0"/>
+          <a:chExt cx="0" cy="0"/>
+        </a:xfrm>
+      </p:grpSpPr>
       <p:sp>
         <p:nvSpPr>
           <p:cNvPr id="2" name="Rectangle 1"/>
@@ -9928,6 +10567,7 @@
           <a:lstStyle/>
           <a:p>
             <a:pPr algn="ctr"/>
+            <a:endParaRPr/>
           </a:p>
         </p:txBody>
       </p:sp>
@@ -9971,6 +10611,7 @@
           <a:lstStyle/>
           <a:p>
             <a:pPr algn="ctr"/>
+            <a:endParaRPr/>
           </a:p>
         </p:txBody>
       </p:sp>
@@ -10014,6 +10655,7 @@
           <a:lstStyle/>
           <a:p>
             <a:pPr algn="ctr"/>
+            <a:endParaRPr/>
           </a:p>
         </p:txBody>
       </p:sp>
@@ -10057,6 +10699,7 @@
           <a:lstStyle/>
           <a:p>
             <a:pPr algn="ctr"/>
+            <a:endParaRPr/>
           </a:p>
         </p:txBody>
       </p:sp>
@@ -10100,6 +10743,7 @@
           <a:lstStyle/>
           <a:p>
             <a:pPr algn="ctr"/>
+            <a:endParaRPr/>
           </a:p>
         </p:txBody>
       </p:sp>
@@ -10143,6 +10787,7 @@
           <a:lstStyle/>
           <a:p>
             <a:pPr algn="ctr"/>
+            <a:endParaRPr/>
           </a:p>
         </p:txBody>
       </p:sp>
@@ -10186,6 +10831,7 @@
           <a:lstStyle/>
           <a:p>
             <a:pPr algn="ctr"/>
+            <a:endParaRPr/>
           </a:p>
         </p:txBody>
       </p:sp>
@@ -10229,6 +10875,7 @@
           <a:lstStyle/>
           <a:p>
             <a:pPr algn="ctr"/>
+            <a:endParaRPr/>
           </a:p>
         </p:txBody>
       </p:sp>
@@ -10270,7 +10917,7 @@
           </a:fontRef>
         </p:style>
         <p:txBody>
-          <a:bodyPr rtlCol="0" anchor="ctr" wrap="none"/>
+          <a:bodyPr wrap="none" rtlCol="0" anchor="ctr"/>
           <a:lstStyle/>
           <a:p>
             <a:pPr algn="ctr">
@@ -10416,11 +11063,11 @@
           </a:fontRef>
         </p:style>
         <p:txBody>
-          <a:bodyPr rtlCol="0" anchor="ctr" wrap="square" lIns="228600" tIns="201168"/>
+          <a:bodyPr wrap="square" lIns="228600" tIns="201168" rtlCol="0" anchor="ctr"/>
           <a:lstStyle/>
           <a:p>
             <a:pPr algn="ctr">
-              <a:defRPr b="1" sz="1200">
+              <a:defRPr sz="1200" b="1">
                 <a:solidFill>
                   <a:srgbClr val="DC2626"/>
                 </a:solidFill>
@@ -10437,7 +11084,7 @@
               </a:spcBef>
             </a:pPr>
             <a:r>
-              <a:rPr b="1" sz="1000">
+              <a:rPr sz="1000" b="1">
                 <a:solidFill>
                   <a:srgbClr val="1E293B"/>
                 </a:solidFill>
@@ -10460,7 +11107,7 @@
               </a:spcBef>
             </a:pPr>
             <a:r>
-              <a:rPr b="1" sz="1000">
+              <a:rPr sz="1000" b="1">
                 <a:solidFill>
                   <a:srgbClr val="1E293B"/>
                 </a:solidFill>
@@ -10483,7 +11130,7 @@
               </a:spcBef>
             </a:pPr>
             <a:r>
-              <a:rPr b="1" sz="1000">
+              <a:rPr sz="1000" b="1">
                 <a:solidFill>
                   <a:srgbClr val="1E293B"/>
                 </a:solidFill>
@@ -10506,7 +11153,7 @@
               </a:spcBef>
             </a:pPr>
             <a:r>
-              <a:rPr b="1" sz="1000">
+              <a:rPr sz="1000" b="1">
                 <a:solidFill>
                   <a:srgbClr val="1E293B"/>
                 </a:solidFill>
@@ -10562,11 +11209,11 @@
           </a:fontRef>
         </p:style>
         <p:txBody>
-          <a:bodyPr rtlCol="0" anchor="ctr" wrap="square" lIns="228600" tIns="201168"/>
+          <a:bodyPr wrap="square" lIns="228600" tIns="201168" rtlCol="0" anchor="ctr"/>
           <a:lstStyle/>
           <a:p>
             <a:pPr algn="ctr">
-              <a:defRPr b="1" sz="1200">
+              <a:defRPr sz="1200" b="1">
                 <a:solidFill>
                   <a:srgbClr val="E11D48"/>
                 </a:solidFill>
@@ -10583,7 +11230,7 @@
               </a:spcBef>
             </a:pPr>
             <a:r>
-              <a:rPr b="1" sz="1000">
+              <a:rPr sz="1000" b="1">
                 <a:solidFill>
                   <a:srgbClr val="E11D48"/>
                 </a:solidFill>
@@ -10606,7 +11253,7 @@
               </a:spcBef>
             </a:pPr>
             <a:r>
-              <a:rPr b="1" sz="1000">
+              <a:rPr sz="1000" b="1">
                 <a:solidFill>
                   <a:srgbClr val="E11D48"/>
                 </a:solidFill>
@@ -10629,7 +11276,7 @@
               </a:spcBef>
             </a:pPr>
             <a:r>
-              <a:rPr b="1" sz="1000">
+              <a:rPr sz="1000" b="1">
                 <a:solidFill>
                   <a:srgbClr val="E11D48"/>
                 </a:solidFill>
@@ -10652,7 +11299,7 @@
               </a:spcBef>
             </a:pPr>
             <a:r>
-              <a:rPr b="1" sz="1000">
+              <a:rPr sz="1000" b="1">
                 <a:solidFill>
                   <a:srgbClr val="E11D48"/>
                 </a:solidFill>
@@ -10712,6 +11359,7 @@
           <a:lstStyle/>
           <a:p>
             <a:pPr algn="ctr"/>
+            <a:endParaRPr/>
           </a:p>
         </p:txBody>
       </p:sp>
@@ -10724,7 +11372,7 @@
           <p:nvPr/>
         </p:nvPicPr>
         <p:blipFill>
-          <a:blip r:embed="rId2"/>
+          <a:blip r:embed="rId3"/>
           <a:stretch>
             <a:fillRect/>
           </a:stretch>
@@ -10777,7 +11425,7 @@
           </a:fontRef>
         </p:style>
         <p:txBody>
-          <a:bodyPr rtlCol="0" anchor="ctr" wrap="square" lIns="137160" rIns="137160" tIns="109728" bIns="91440"/>
+          <a:bodyPr wrap="square" lIns="137160" tIns="109728" rIns="137160" bIns="91440" rtlCol="0" anchor="ctr"/>
           <a:lstStyle/>
           <a:p>
             <a:pPr algn="ctr">
@@ -10816,7 +11464,7 @@
 </file>
 
 <file path=ppt/slides/slide4.xml><?xml version="1.0" encoding="utf-8"?>
-<p:sld xmlns:a="http://schemas.openxmlformats.org/drawingml/2006/main" xmlns:p="http://schemas.openxmlformats.org/presentationml/2006/main" xmlns:r="http://schemas.openxmlformats.org/officeDocument/2006/relationships">
+<p:sld xmlns:a="http://schemas.openxmlformats.org/drawingml/2006/main" xmlns:r="http://schemas.openxmlformats.org/officeDocument/2006/relationships" xmlns:p="http://schemas.openxmlformats.org/presentationml/2006/main">
   <p:cSld>
     <p:spTree>
       <p:nvGrpSpPr>
@@ -10824,7 +11472,14 @@
         <p:cNvGrpSpPr/>
         <p:nvPr/>
       </p:nvGrpSpPr>
-      <p:grpSpPr/>
+      <p:grpSpPr>
+        <a:xfrm>
+          <a:off x="0" y="0"/>
+          <a:ext cx="0" cy="0"/>
+          <a:chOff x="0" y="0"/>
+          <a:chExt cx="0" cy="0"/>
+        </a:xfrm>
+      </p:grpSpPr>
       <p:sp>
         <p:nvSpPr>
           <p:cNvPr id="2" name="Rectangle 1"/>
@@ -10865,6 +11520,7 @@
           <a:lstStyle/>
           <a:p>
             <a:pPr algn="ctr"/>
+            <a:endParaRPr/>
           </a:p>
         </p:txBody>
       </p:sp>
@@ -10908,6 +11564,7 @@
           <a:lstStyle/>
           <a:p>
             <a:pPr algn="ctr"/>
+            <a:endParaRPr/>
           </a:p>
         </p:txBody>
       </p:sp>
@@ -10951,6 +11608,7 @@
           <a:lstStyle/>
           <a:p>
             <a:pPr algn="ctr"/>
+            <a:endParaRPr/>
           </a:p>
         </p:txBody>
       </p:sp>
@@ -10994,6 +11652,7 @@
           <a:lstStyle/>
           <a:p>
             <a:pPr algn="ctr"/>
+            <a:endParaRPr/>
           </a:p>
         </p:txBody>
       </p:sp>
@@ -11037,6 +11696,7 @@
           <a:lstStyle/>
           <a:p>
             <a:pPr algn="ctr"/>
+            <a:endParaRPr/>
           </a:p>
         </p:txBody>
       </p:sp>
@@ -11080,6 +11740,7 @@
           <a:lstStyle/>
           <a:p>
             <a:pPr algn="ctr"/>
+            <a:endParaRPr/>
           </a:p>
         </p:txBody>
       </p:sp>
@@ -11123,6 +11784,7 @@
           <a:lstStyle/>
           <a:p>
             <a:pPr algn="ctr"/>
+            <a:endParaRPr/>
           </a:p>
         </p:txBody>
       </p:sp>
@@ -11166,6 +11828,7 @@
           <a:lstStyle/>
           <a:p>
             <a:pPr algn="ctr"/>
+            <a:endParaRPr/>
           </a:p>
         </p:txBody>
       </p:sp>
@@ -11207,7 +11870,7 @@
           </a:fontRef>
         </p:style>
         <p:txBody>
-          <a:bodyPr rtlCol="0" anchor="ctr" wrap="none"/>
+          <a:bodyPr wrap="none" rtlCol="0" anchor="ctr"/>
           <a:lstStyle/>
           <a:p>
             <a:pPr algn="ctr">
@@ -11353,11 +12016,11 @@
           </a:fontRef>
         </p:style>
         <p:txBody>
-          <a:bodyPr rtlCol="0" anchor="ctr" wrap="square" lIns="109728" rIns="109728" tIns="164592"/>
+          <a:bodyPr wrap="square" lIns="109728" tIns="164592" rIns="109728" rtlCol="0" anchor="ctr"/>
           <a:lstStyle/>
           <a:p>
             <a:pPr algn="ctr">
-              <a:defRPr b="1" sz="1000">
+              <a:defRPr sz="1000" b="1">
                 <a:solidFill>
                   <a:srgbClr val="E11D48"/>
                 </a:solidFill>
@@ -11491,11 +12154,11 @@
           </a:fontRef>
         </p:style>
         <p:txBody>
-          <a:bodyPr rtlCol="0" anchor="ctr" wrap="square" lIns="109728" rIns="109728" tIns="164592"/>
+          <a:bodyPr wrap="square" lIns="109728" tIns="164592" rIns="109728" rtlCol="0" anchor="ctr"/>
           <a:lstStyle/>
           <a:p>
             <a:pPr algn="ctr">
-              <a:defRPr b="1" sz="1000">
+              <a:defRPr sz="1000" b="1">
                 <a:solidFill>
                   <a:srgbClr val="8B5CF6"/>
                 </a:solidFill>
@@ -11629,11 +12292,11 @@
           </a:fontRef>
         </p:style>
         <p:txBody>
-          <a:bodyPr rtlCol="0" anchor="ctr" wrap="square" lIns="109728" rIns="109728" tIns="164592"/>
+          <a:bodyPr wrap="square" lIns="109728" tIns="164592" rIns="109728" rtlCol="0" anchor="ctr"/>
           <a:lstStyle/>
           <a:p>
             <a:pPr algn="ctr">
-              <a:defRPr b="1" sz="1000">
+              <a:defRPr sz="1000" b="1">
                 <a:solidFill>
                   <a:srgbClr val="FF5C8A"/>
                 </a:solidFill>
@@ -11767,11 +12430,11 @@
           </a:fontRef>
         </p:style>
         <p:txBody>
-          <a:bodyPr rtlCol="0" anchor="ctr" wrap="square" lIns="109728" rIns="109728" tIns="164592"/>
+          <a:bodyPr wrap="square" lIns="109728" tIns="164592" rIns="109728" rtlCol="0" anchor="ctr"/>
           <a:lstStyle/>
           <a:p>
             <a:pPr algn="ctr">
-              <a:defRPr b="1" sz="1000">
+              <a:defRPr sz="1000" b="1">
                 <a:solidFill>
                   <a:srgbClr val="F59E0B"/>
                 </a:solidFill>
@@ -11905,11 +12568,11 @@
           </a:fontRef>
         </p:style>
         <p:txBody>
-          <a:bodyPr rtlCol="0" anchor="ctr" wrap="square" lIns="109728" rIns="109728" tIns="164592"/>
+          <a:bodyPr wrap="square" lIns="109728" tIns="164592" rIns="109728" rtlCol="0" anchor="ctr"/>
           <a:lstStyle/>
           <a:p>
             <a:pPr algn="ctr">
-              <a:defRPr b="1" sz="1000">
+              <a:defRPr sz="1000" b="1">
                 <a:solidFill>
                   <a:srgbClr val="10B981"/>
                 </a:solidFill>
@@ -12047,6 +12710,7 @@
           <a:lstStyle/>
           <a:p>
             <a:pPr algn="ctr"/>
+            <a:endParaRPr/>
           </a:p>
         </p:txBody>
       </p:sp>
@@ -12112,7 +12776,7 @@
           </a:fontRef>
         </p:style>
         <p:txBody>
-          <a:bodyPr rtlCol="0" anchor="ctr" wrap="square" lIns="137160" rIns="137160" tIns="109728" bIns="91440"/>
+          <a:bodyPr wrap="square" lIns="137160" tIns="109728" rIns="137160" bIns="91440" rtlCol="0" anchor="ctr"/>
           <a:lstStyle/>
           <a:p>
             <a:pPr algn="ctr">
@@ -12151,7 +12815,7 @@
 </file>
 
 <file path=ppt/slides/slide5.xml><?xml version="1.0" encoding="utf-8"?>
-<p:sld xmlns:a="http://schemas.openxmlformats.org/drawingml/2006/main" xmlns:p="http://schemas.openxmlformats.org/presentationml/2006/main" xmlns:r="http://schemas.openxmlformats.org/officeDocument/2006/relationships">
+<p:sld xmlns:a="http://schemas.openxmlformats.org/drawingml/2006/main" xmlns:r="http://schemas.openxmlformats.org/officeDocument/2006/relationships" xmlns:p="http://schemas.openxmlformats.org/presentationml/2006/main">
   <p:cSld>
     <p:spTree>
       <p:nvGrpSpPr>
@@ -12159,7 +12823,14 @@
         <p:cNvGrpSpPr/>
         <p:nvPr/>
       </p:nvGrpSpPr>
-      <p:grpSpPr/>
+      <p:grpSpPr>
+        <a:xfrm>
+          <a:off x="0" y="0"/>
+          <a:ext cx="0" cy="0"/>
+          <a:chOff x="0" y="0"/>
+          <a:chExt cx="0" cy="0"/>
+        </a:xfrm>
+      </p:grpSpPr>
       <p:sp>
         <p:nvSpPr>
           <p:cNvPr id="2" name="Rectangle 1"/>
@@ -12200,6 +12871,7 @@
           <a:lstStyle/>
           <a:p>
             <a:pPr algn="ctr"/>
+            <a:endParaRPr/>
           </a:p>
         </p:txBody>
       </p:sp>
@@ -12243,6 +12915,7 @@
           <a:lstStyle/>
           <a:p>
             <a:pPr algn="ctr"/>
+            <a:endParaRPr/>
           </a:p>
         </p:txBody>
       </p:sp>
@@ -12286,6 +12959,7 @@
           <a:lstStyle/>
           <a:p>
             <a:pPr algn="ctr"/>
+            <a:endParaRPr/>
           </a:p>
         </p:txBody>
       </p:sp>
@@ -12329,6 +13003,7 @@
           <a:lstStyle/>
           <a:p>
             <a:pPr algn="ctr"/>
+            <a:endParaRPr/>
           </a:p>
         </p:txBody>
       </p:sp>
@@ -12372,6 +13047,7 @@
           <a:lstStyle/>
           <a:p>
             <a:pPr algn="ctr"/>
+            <a:endParaRPr/>
           </a:p>
         </p:txBody>
       </p:sp>
@@ -12415,6 +13091,7 @@
           <a:lstStyle/>
           <a:p>
             <a:pPr algn="ctr"/>
+            <a:endParaRPr/>
           </a:p>
         </p:txBody>
       </p:sp>
@@ -12458,6 +13135,7 @@
           <a:lstStyle/>
           <a:p>
             <a:pPr algn="ctr"/>
+            <a:endParaRPr/>
           </a:p>
         </p:txBody>
       </p:sp>
@@ -12501,6 +13179,7 @@
           <a:lstStyle/>
           <a:p>
             <a:pPr algn="ctr"/>
+            <a:endParaRPr/>
           </a:p>
         </p:txBody>
       </p:sp>
@@ -12542,7 +13221,7 @@
           </a:fontRef>
         </p:style>
         <p:txBody>
-          <a:bodyPr rtlCol="0" anchor="ctr" wrap="none"/>
+          <a:bodyPr wrap="none" rtlCol="0" anchor="ctr"/>
           <a:lstStyle/>
           <a:p>
             <a:pPr algn="ctr">
@@ -12688,11 +13367,11 @@
           </a:fontRef>
         </p:style>
         <p:txBody>
-          <a:bodyPr rtlCol="0" anchor="ctr" wrap="square" lIns="228600" tIns="201168"/>
+          <a:bodyPr wrap="square" lIns="228600" tIns="201168" rtlCol="0" anchor="ctr"/>
           <a:lstStyle/>
           <a:p>
             <a:pPr algn="ctr">
-              <a:defRPr b="1" sz="1200">
+              <a:defRPr sz="1200" b="1">
                 <a:solidFill>
                   <a:srgbClr val="E11D48"/>
                 </a:solidFill>
@@ -12707,7 +13386,7 @@
               <a:spcBef>
                 <a:spcPts val="400"/>
               </a:spcBef>
-              <a:defRPr b="1" sz="1000">
+              <a:defRPr sz="1000" b="1">
                 <a:solidFill>
                   <a:srgbClr val="FF5C8A"/>
                 </a:solidFill>
@@ -12724,7 +13403,7 @@
               </a:spcBef>
             </a:pPr>
             <a:r>
-              <a:rPr b="1" sz="950">
+              <a:rPr sz="950" b="1">
                 <a:solidFill>
                   <a:srgbClr val="1E293B"/>
                 </a:solidFill>
@@ -12747,7 +13426,7 @@
               </a:spcBef>
             </a:pPr>
             <a:r>
-              <a:rPr b="1" sz="950">
+              <a:rPr sz="950" b="1">
                 <a:solidFill>
                   <a:srgbClr val="1E293B"/>
                 </a:solidFill>
@@ -12770,7 +13449,7 @@
               </a:spcBef>
             </a:pPr>
             <a:r>
-              <a:rPr b="1" sz="950">
+              <a:rPr sz="950" b="1">
                 <a:solidFill>
                   <a:srgbClr val="1E293B"/>
                 </a:solidFill>
@@ -12793,7 +13472,7 @@
               </a:spcBef>
             </a:pPr>
             <a:r>
-              <a:rPr b="1" sz="950">
+              <a:rPr sz="950" b="1">
                 <a:solidFill>
                   <a:srgbClr val="1E293B"/>
                 </a:solidFill>
@@ -12816,7 +13495,7 @@
               </a:spcBef>
             </a:pPr>
             <a:r>
-              <a:rPr b="1" sz="950">
+              <a:rPr sz="950" b="1">
                 <a:solidFill>
                   <a:srgbClr val="1E293B"/>
                 </a:solidFill>
@@ -12872,11 +13551,11 @@
           </a:fontRef>
         </p:style>
         <p:txBody>
-          <a:bodyPr rtlCol="0" anchor="ctr" wrap="square" lIns="228600" tIns="201168"/>
+          <a:bodyPr wrap="square" lIns="228600" tIns="201168" rtlCol="0" anchor="ctr"/>
           <a:lstStyle/>
           <a:p>
             <a:pPr algn="ctr">
-              <a:defRPr b="1" sz="1200">
+              <a:defRPr sz="1200" b="1">
                 <a:solidFill>
                   <a:srgbClr val="10B981"/>
                 </a:solidFill>
@@ -12893,7 +13572,7 @@
               </a:spcBef>
             </a:pPr>
             <a:r>
-              <a:rPr b="1" sz="950">
+              <a:rPr sz="950" b="1">
                 <a:solidFill>
                   <a:srgbClr val="10B981"/>
                 </a:solidFill>
@@ -12916,7 +13595,7 @@
               </a:spcBef>
             </a:pPr>
             <a:r>
-              <a:rPr b="1" sz="950">
+              <a:rPr sz="950" b="1">
                 <a:solidFill>
                   <a:srgbClr val="10B981"/>
                 </a:solidFill>
@@ -12939,7 +13618,7 @@
               </a:spcBef>
             </a:pPr>
             <a:r>
-              <a:rPr b="1" sz="950">
+              <a:rPr sz="950" b="1">
                 <a:solidFill>
                   <a:srgbClr val="10B981"/>
                 </a:solidFill>
@@ -12962,7 +13641,7 @@
               </a:spcBef>
             </a:pPr>
             <a:r>
-              <a:rPr b="1" sz="950">
+              <a:rPr sz="950" b="1">
                 <a:solidFill>
                   <a:srgbClr val="10B981"/>
                 </a:solidFill>
@@ -12985,7 +13664,7 @@
               </a:spcBef>
             </a:pPr>
             <a:r>
-              <a:rPr b="1" sz="950">
+              <a:rPr sz="950" b="1">
                 <a:solidFill>
                   <a:srgbClr val="10B981"/>
                 </a:solidFill>
@@ -13045,6 +13724,7 @@
           <a:lstStyle/>
           <a:p>
             <a:pPr algn="ctr"/>
+            <a:endParaRPr/>
           </a:p>
         </p:txBody>
       </p:sp>
@@ -13057,7 +13737,7 @@
           <p:nvPr/>
         </p:nvPicPr>
         <p:blipFill>
-          <a:blip r:embed="rId2"/>
+          <a:blip r:embed="rId3"/>
           <a:stretch>
             <a:fillRect/>
           </a:stretch>
@@ -13110,7 +13790,7 @@
           </a:fontRef>
         </p:style>
         <p:txBody>
-          <a:bodyPr rtlCol="0" anchor="ctr" wrap="square" lIns="137160" rIns="137160" tIns="109728" bIns="91440"/>
+          <a:bodyPr wrap="square" lIns="137160" tIns="109728" rIns="137160" bIns="91440" rtlCol="0" anchor="ctr"/>
           <a:lstStyle/>
           <a:p>
             <a:pPr algn="ctr">
@@ -13149,7 +13829,7 @@
 </file>
 
 <file path=ppt/slides/slide6.xml><?xml version="1.0" encoding="utf-8"?>
-<p:sld xmlns:a="http://schemas.openxmlformats.org/drawingml/2006/main" xmlns:p="http://schemas.openxmlformats.org/presentationml/2006/main" xmlns:r="http://schemas.openxmlformats.org/officeDocument/2006/relationships">
+<p:sld xmlns:a="http://schemas.openxmlformats.org/drawingml/2006/main" xmlns:r="http://schemas.openxmlformats.org/officeDocument/2006/relationships" xmlns:p="http://schemas.openxmlformats.org/presentationml/2006/main">
   <p:cSld>
     <p:spTree>
       <p:nvGrpSpPr>
@@ -13157,7 +13837,14 @@
         <p:cNvGrpSpPr/>
         <p:nvPr/>
       </p:nvGrpSpPr>
-      <p:grpSpPr/>
+      <p:grpSpPr>
+        <a:xfrm>
+          <a:off x="0" y="0"/>
+          <a:ext cx="0" cy="0"/>
+          <a:chOff x="0" y="0"/>
+          <a:chExt cx="0" cy="0"/>
+        </a:xfrm>
+      </p:grpSpPr>
       <p:sp>
         <p:nvSpPr>
           <p:cNvPr id="2" name="Rectangle 1"/>
@@ -13198,6 +13885,7 @@
           <a:lstStyle/>
           <a:p>
             <a:pPr algn="ctr"/>
+            <a:endParaRPr/>
           </a:p>
         </p:txBody>
       </p:sp>
@@ -13241,6 +13929,7 @@
           <a:lstStyle/>
           <a:p>
             <a:pPr algn="ctr"/>
+            <a:endParaRPr/>
           </a:p>
         </p:txBody>
       </p:sp>
@@ -13284,6 +13973,7 @@
           <a:lstStyle/>
           <a:p>
             <a:pPr algn="ctr"/>
+            <a:endParaRPr/>
           </a:p>
         </p:txBody>
       </p:sp>
@@ -13327,6 +14017,7 @@
           <a:lstStyle/>
           <a:p>
             <a:pPr algn="ctr"/>
+            <a:endParaRPr/>
           </a:p>
         </p:txBody>
       </p:sp>
@@ -13370,6 +14061,7 @@
           <a:lstStyle/>
           <a:p>
             <a:pPr algn="ctr"/>
+            <a:endParaRPr/>
           </a:p>
         </p:txBody>
       </p:sp>
@@ -13413,6 +14105,7 @@
           <a:lstStyle/>
           <a:p>
             <a:pPr algn="ctr"/>
+            <a:endParaRPr/>
           </a:p>
         </p:txBody>
       </p:sp>
@@ -13456,6 +14149,7 @@
           <a:lstStyle/>
           <a:p>
             <a:pPr algn="ctr"/>
+            <a:endParaRPr/>
           </a:p>
         </p:txBody>
       </p:sp>
@@ -13499,6 +14193,7 @@
           <a:lstStyle/>
           <a:p>
             <a:pPr algn="ctr"/>
+            <a:endParaRPr/>
           </a:p>
         </p:txBody>
       </p:sp>
@@ -13540,7 +14235,7 @@
           </a:fontRef>
         </p:style>
         <p:txBody>
-          <a:bodyPr rtlCol="0" anchor="ctr" wrap="none"/>
+          <a:bodyPr wrap="none" rtlCol="0" anchor="ctr"/>
           <a:lstStyle/>
           <a:p>
             <a:pPr algn="ctr">
@@ -13667,11 +14362,41 @@
                 <a:tableStyleId>{5C22544A-7EE6-4342-B048-85BDC9FD1C3A}</a:tableStyleId>
               </a:tblPr>
               <a:tblGrid>
-                <a:gridCol w="1005840"/>
-                <a:gridCol w="4114800"/>
-                <a:gridCol w="2011680"/>
-                <a:gridCol w="1463040"/>
-                <a:gridCol w="2133295"/>
+                <a:gridCol w="1005840">
+                  <a:extLst>
+                    <a:ext uri="{9D8B030D-6E8A-4147-A177-3AD203B41FA5}">
+                      <a16:colId xmlns:a16="http://schemas.microsoft.com/office/drawing/2014/main" val="20000"/>
+                    </a:ext>
+                  </a:extLst>
+                </a:gridCol>
+                <a:gridCol w="4114800">
+                  <a:extLst>
+                    <a:ext uri="{9D8B030D-6E8A-4147-A177-3AD203B41FA5}">
+                      <a16:colId xmlns:a16="http://schemas.microsoft.com/office/drawing/2014/main" val="20001"/>
+                    </a:ext>
+                  </a:extLst>
+                </a:gridCol>
+                <a:gridCol w="2011680">
+                  <a:extLst>
+                    <a:ext uri="{9D8B030D-6E8A-4147-A177-3AD203B41FA5}">
+                      <a16:colId xmlns:a16="http://schemas.microsoft.com/office/drawing/2014/main" val="20002"/>
+                    </a:ext>
+                  </a:extLst>
+                </a:gridCol>
+                <a:gridCol w="1463040">
+                  <a:extLst>
+                    <a:ext uri="{9D8B030D-6E8A-4147-A177-3AD203B41FA5}">
+                      <a16:colId xmlns:a16="http://schemas.microsoft.com/office/drawing/2014/main" val="20003"/>
+                    </a:ext>
+                  </a:extLst>
+                </a:gridCol>
+                <a:gridCol w="2133295">
+                  <a:extLst>
+                    <a:ext uri="{9D8B030D-6E8A-4147-A177-3AD203B41FA5}">
+                      <a16:colId xmlns:a16="http://schemas.microsoft.com/office/drawing/2014/main" val="20004"/>
+                    </a:ext>
+                  </a:extLst>
+                </a:gridCol>
               </a:tblGrid>
               <a:tr h="349134">
                 <a:tc>
@@ -13680,7 +14405,7 @@
                     <a:lstStyle/>
                     <a:p>
                       <a:pPr algn="ctr">
-                        <a:defRPr b="1" sz="1000">
+                        <a:defRPr sz="1000" b="1">
                           <a:solidFill>
                             <a:srgbClr val="FFFFFF"/>
                           </a:solidFill>
@@ -13703,7 +14428,7 @@
                     <a:lstStyle/>
                     <a:p>
                       <a:pPr algn="ctr">
-                        <a:defRPr b="1" sz="1000">
+                        <a:defRPr sz="1000" b="1">
                           <a:solidFill>
                             <a:srgbClr val="FFFFFF"/>
                           </a:solidFill>
@@ -13726,7 +14451,7 @@
                     <a:lstStyle/>
                     <a:p>
                       <a:pPr algn="ctr">
-                        <a:defRPr b="1" sz="1000">
+                        <a:defRPr sz="1000" b="1">
                           <a:solidFill>
                             <a:srgbClr val="FFFFFF"/>
                           </a:solidFill>
@@ -13749,7 +14474,7 @@
                     <a:lstStyle/>
                     <a:p>
                       <a:pPr algn="ctr">
-                        <a:defRPr b="1" sz="1000">
+                        <a:defRPr sz="1000" b="1">
                           <a:solidFill>
                             <a:srgbClr val="FFFFFF"/>
                           </a:solidFill>
@@ -13772,7 +14497,7 @@
                     <a:lstStyle/>
                     <a:p>
                       <a:pPr algn="ctr">
-                        <a:defRPr b="1" sz="1000">
+                        <a:defRPr sz="1000" b="1">
                           <a:solidFill>
                             <a:srgbClr val="FFFFFF"/>
                           </a:solidFill>
@@ -13789,6 +14514,11 @@
                     </a:solidFill>
                   </a:tcPr>
                 </a:tc>
+                <a:extLst>
+                  <a:ext uri="{0D108BD9-81ED-4DB2-BD59-A6C34878D82A}">
+                    <a16:rowId xmlns:a16="http://schemas.microsoft.com/office/drawing/2014/main" val="10000"/>
+                  </a:ext>
+                </a:extLst>
               </a:tr>
               <a:tr h="349134">
                 <a:tc>
@@ -13894,6 +14624,11 @@
                     </a:solidFill>
                   </a:tcPr>
                 </a:tc>
+                <a:extLst>
+                  <a:ext uri="{0D108BD9-81ED-4DB2-BD59-A6C34878D82A}">
+                    <a16:rowId xmlns:a16="http://schemas.microsoft.com/office/drawing/2014/main" val="10001"/>
+                  </a:ext>
+                </a:extLst>
               </a:tr>
               <a:tr h="349134">
                 <a:tc>
@@ -13999,6 +14734,11 @@
                     </a:solidFill>
                   </a:tcPr>
                 </a:tc>
+                <a:extLst>
+                  <a:ext uri="{0D108BD9-81ED-4DB2-BD59-A6C34878D82A}">
+                    <a16:rowId xmlns:a16="http://schemas.microsoft.com/office/drawing/2014/main" val="10002"/>
+                  </a:ext>
+                </a:extLst>
               </a:tr>
               <a:tr h="349134">
                 <a:tc>
@@ -14104,6 +14844,11 @@
                     </a:solidFill>
                   </a:tcPr>
                 </a:tc>
+                <a:extLst>
+                  <a:ext uri="{0D108BD9-81ED-4DB2-BD59-A6C34878D82A}">
+                    <a16:rowId xmlns:a16="http://schemas.microsoft.com/office/drawing/2014/main" val="10003"/>
+                  </a:ext>
+                </a:extLst>
               </a:tr>
               <a:tr h="349134">
                 <a:tc>
@@ -14209,6 +14954,11 @@
                     </a:solidFill>
                   </a:tcPr>
                 </a:tc>
+                <a:extLst>
+                  <a:ext uri="{0D108BD9-81ED-4DB2-BD59-A6C34878D82A}">
+                    <a16:rowId xmlns:a16="http://schemas.microsoft.com/office/drawing/2014/main" val="10004"/>
+                  </a:ext>
+                </a:extLst>
               </a:tr>
               <a:tr h="349134">
                 <a:tc>
@@ -14314,6 +15064,11 @@
                     </a:solidFill>
                   </a:tcPr>
                 </a:tc>
+                <a:extLst>
+                  <a:ext uri="{0D108BD9-81ED-4DB2-BD59-A6C34878D82A}">
+                    <a16:rowId xmlns:a16="http://schemas.microsoft.com/office/drawing/2014/main" val="10005"/>
+                  </a:ext>
+                </a:extLst>
               </a:tr>
               <a:tr h="349134">
                 <a:tc>
@@ -14419,6 +15174,11 @@
                     </a:solidFill>
                   </a:tcPr>
                 </a:tc>
+                <a:extLst>
+                  <a:ext uri="{0D108BD9-81ED-4DB2-BD59-A6C34878D82A}">
+                    <a16:rowId xmlns:a16="http://schemas.microsoft.com/office/drawing/2014/main" val="10006"/>
+                  </a:ext>
+                </a:extLst>
               </a:tr>
               <a:tr h="349134">
                 <a:tc>
@@ -14524,6 +15284,11 @@
                     </a:solidFill>
                   </a:tcPr>
                 </a:tc>
+                <a:extLst>
+                  <a:ext uri="{0D108BD9-81ED-4DB2-BD59-A6C34878D82A}">
+                    <a16:rowId xmlns:a16="http://schemas.microsoft.com/office/drawing/2014/main" val="10007"/>
+                  </a:ext>
+                </a:extLst>
               </a:tr>
               <a:tr h="349134">
                 <a:tc>
@@ -14629,6 +15394,11 @@
                     </a:solidFill>
                   </a:tcPr>
                 </a:tc>
+                <a:extLst>
+                  <a:ext uri="{0D108BD9-81ED-4DB2-BD59-A6C34878D82A}">
+                    <a16:rowId xmlns:a16="http://schemas.microsoft.com/office/drawing/2014/main" val="10008"/>
+                  </a:ext>
+                </a:extLst>
               </a:tr>
               <a:tr h="349134">
                 <a:tc>
@@ -14734,6 +15504,11 @@
                     </a:solidFill>
                   </a:tcPr>
                 </a:tc>
+                <a:extLst>
+                  <a:ext uri="{0D108BD9-81ED-4DB2-BD59-A6C34878D82A}">
+                    <a16:rowId xmlns:a16="http://schemas.microsoft.com/office/drawing/2014/main" val="10009"/>
+                  </a:ext>
+                </a:extLst>
               </a:tr>
               <a:tr h="349140">
                 <a:tc>
@@ -14839,6 +15614,11 @@
                     </a:solidFill>
                   </a:tcPr>
                 </a:tc>
+                <a:extLst>
+                  <a:ext uri="{0D108BD9-81ED-4DB2-BD59-A6C34878D82A}">
+                    <a16:rowId xmlns:a16="http://schemas.microsoft.com/office/drawing/2014/main" val="10010"/>
+                  </a:ext>
+                </a:extLst>
               </a:tr>
             </a:tbl>
           </a:graphicData>
@@ -14886,6 +15666,7 @@
           <a:lstStyle/>
           <a:p>
             <a:pPr algn="ctr"/>
+            <a:endParaRPr/>
           </a:p>
         </p:txBody>
       </p:sp>
@@ -14951,7 +15732,7 @@
           </a:fontRef>
         </p:style>
         <p:txBody>
-          <a:bodyPr rtlCol="0" anchor="ctr" wrap="square" lIns="137160" rIns="137160" tIns="109728" bIns="91440"/>
+          <a:bodyPr wrap="square" lIns="137160" tIns="109728" rIns="137160" bIns="91440" rtlCol="0" anchor="ctr"/>
           <a:lstStyle/>
           <a:p>
             <a:pPr algn="ctr">
@@ -14990,7 +15771,7 @@
 </file>
 
 <file path=ppt/slides/slide7.xml><?xml version="1.0" encoding="utf-8"?>
-<p:sld xmlns:a="http://schemas.openxmlformats.org/drawingml/2006/main" xmlns:p="http://schemas.openxmlformats.org/presentationml/2006/main" xmlns:r="http://schemas.openxmlformats.org/officeDocument/2006/relationships">
+<p:sld xmlns:a="http://schemas.openxmlformats.org/drawingml/2006/main" xmlns:r="http://schemas.openxmlformats.org/officeDocument/2006/relationships" xmlns:p="http://schemas.openxmlformats.org/presentationml/2006/main">
   <p:cSld>
     <p:spTree>
       <p:nvGrpSpPr>
@@ -14998,7 +15779,14 @@
         <p:cNvGrpSpPr/>
         <p:nvPr/>
       </p:nvGrpSpPr>
-      <p:grpSpPr/>
+      <p:grpSpPr>
+        <a:xfrm>
+          <a:off x="0" y="0"/>
+          <a:ext cx="0" cy="0"/>
+          <a:chOff x="0" y="0"/>
+          <a:chExt cx="0" cy="0"/>
+        </a:xfrm>
+      </p:grpSpPr>
       <p:sp>
         <p:nvSpPr>
           <p:cNvPr id="2" name="Rectangle 1"/>
@@ -15039,6 +15827,7 @@
           <a:lstStyle/>
           <a:p>
             <a:pPr algn="ctr"/>
+            <a:endParaRPr/>
           </a:p>
         </p:txBody>
       </p:sp>
@@ -15082,6 +15871,7 @@
           <a:lstStyle/>
           <a:p>
             <a:pPr algn="ctr"/>
+            <a:endParaRPr/>
           </a:p>
         </p:txBody>
       </p:sp>
@@ -15125,6 +15915,7 @@
           <a:lstStyle/>
           <a:p>
             <a:pPr algn="ctr"/>
+            <a:endParaRPr/>
           </a:p>
         </p:txBody>
       </p:sp>
@@ -15168,6 +15959,7 @@
           <a:lstStyle/>
           <a:p>
             <a:pPr algn="ctr"/>
+            <a:endParaRPr/>
           </a:p>
         </p:txBody>
       </p:sp>
@@ -15211,6 +16003,7 @@
           <a:lstStyle/>
           <a:p>
             <a:pPr algn="ctr"/>
+            <a:endParaRPr/>
           </a:p>
         </p:txBody>
       </p:sp>
@@ -15254,6 +16047,7 @@
           <a:lstStyle/>
           <a:p>
             <a:pPr algn="ctr"/>
+            <a:endParaRPr/>
           </a:p>
         </p:txBody>
       </p:sp>
@@ -15297,6 +16091,7 @@
           <a:lstStyle/>
           <a:p>
             <a:pPr algn="ctr"/>
+            <a:endParaRPr/>
           </a:p>
         </p:txBody>
       </p:sp>
@@ -15340,6 +16135,7 @@
           <a:lstStyle/>
           <a:p>
             <a:pPr algn="ctr"/>
+            <a:endParaRPr/>
           </a:p>
         </p:txBody>
       </p:sp>
@@ -15381,7 +16177,7 @@
           </a:fontRef>
         </p:style>
         <p:txBody>
-          <a:bodyPr rtlCol="0" anchor="ctr" wrap="none"/>
+          <a:bodyPr wrap="none" rtlCol="0" anchor="ctr"/>
           <a:lstStyle/>
           <a:p>
             <a:pPr algn="ctr">
@@ -15531,6 +16327,7 @@
           <a:lstStyle/>
           <a:p>
             <a:pPr algn="ctr"/>
+            <a:endParaRPr/>
           </a:p>
         </p:txBody>
       </p:sp>
@@ -15596,11 +16393,11 @@
           </a:fontRef>
         </p:style>
         <p:txBody>
-          <a:bodyPr rtlCol="0" anchor="ctr" wrap="square" lIns="182880" tIns="182880"/>
+          <a:bodyPr wrap="square" lIns="182880" tIns="182880" rtlCol="0" anchor="ctr"/>
           <a:lstStyle/>
           <a:p>
             <a:pPr algn="ctr">
-              <a:defRPr b="1" sz="1100">
+              <a:defRPr sz="1100" b="1">
                 <a:solidFill>
                   <a:srgbClr val="E11D48"/>
                 </a:solidFill>
@@ -15617,7 +16414,7 @@
               </a:spcBef>
             </a:pPr>
             <a:r>
-              <a:rPr b="1" sz="950">
+              <a:rPr sz="950" b="1">
                 <a:solidFill>
                   <a:srgbClr val="1E293B"/>
                 </a:solidFill>
@@ -15640,7 +16437,7 @@
               </a:spcBef>
             </a:pPr>
             <a:r>
-              <a:rPr b="1" sz="950">
+              <a:rPr sz="950" b="1">
                 <a:solidFill>
                   <a:srgbClr val="1E293B"/>
                 </a:solidFill>
@@ -15663,7 +16460,7 @@
               </a:spcBef>
             </a:pPr>
             <a:r>
-              <a:rPr b="1" sz="950">
+              <a:rPr sz="950" b="1">
                 <a:solidFill>
                   <a:srgbClr val="1E293B"/>
                 </a:solidFill>
@@ -15686,7 +16483,7 @@
               </a:spcBef>
             </a:pPr>
             <a:r>
-              <a:rPr b="1" sz="950">
+              <a:rPr sz="950" b="1">
                 <a:solidFill>
                   <a:srgbClr val="1E293B"/>
                 </a:solidFill>
@@ -15709,7 +16506,7 @@
               </a:spcBef>
             </a:pPr>
             <a:r>
-              <a:rPr b="1" sz="950">
+              <a:rPr sz="950" b="1">
                 <a:solidFill>
                   <a:srgbClr val="1E293B"/>
                 </a:solidFill>
@@ -15769,6 +16566,7 @@
           <a:lstStyle/>
           <a:p>
             <a:pPr algn="ctr"/>
+            <a:endParaRPr/>
           </a:p>
         </p:txBody>
       </p:sp>
@@ -15834,7 +16632,7 @@
           </a:fontRef>
         </p:style>
         <p:txBody>
-          <a:bodyPr rtlCol="0" anchor="ctr" wrap="square" lIns="137160" rIns="137160" tIns="109728" bIns="91440"/>
+          <a:bodyPr wrap="square" lIns="137160" tIns="109728" rIns="137160" bIns="91440" rtlCol="0" anchor="ctr"/>
           <a:lstStyle/>
           <a:p>
             <a:pPr algn="ctr">
@@ -15873,7 +16671,7 @@
 </file>
 
 <file path=ppt/slides/slide8.xml><?xml version="1.0" encoding="utf-8"?>
-<p:sld xmlns:a="http://schemas.openxmlformats.org/drawingml/2006/main" xmlns:p="http://schemas.openxmlformats.org/presentationml/2006/main" xmlns:r="http://schemas.openxmlformats.org/officeDocument/2006/relationships">
+<p:sld xmlns:a="http://schemas.openxmlformats.org/drawingml/2006/main" xmlns:r="http://schemas.openxmlformats.org/officeDocument/2006/relationships" xmlns:p="http://schemas.openxmlformats.org/presentationml/2006/main">
   <p:cSld>
     <p:spTree>
       <p:nvGrpSpPr>
@@ -15881,7 +16679,14 @@
         <p:cNvGrpSpPr/>
         <p:nvPr/>
       </p:nvGrpSpPr>
-      <p:grpSpPr/>
+      <p:grpSpPr>
+        <a:xfrm>
+          <a:off x="0" y="0"/>
+          <a:ext cx="0" cy="0"/>
+          <a:chOff x="0" y="0"/>
+          <a:chExt cx="0" cy="0"/>
+        </a:xfrm>
+      </p:grpSpPr>
       <p:sp>
         <p:nvSpPr>
           <p:cNvPr id="2" name="Rectangle 1"/>
@@ -15922,6 +16727,7 @@
           <a:lstStyle/>
           <a:p>
             <a:pPr algn="ctr"/>
+            <a:endParaRPr/>
           </a:p>
         </p:txBody>
       </p:sp>
@@ -15965,6 +16771,7 @@
           <a:lstStyle/>
           <a:p>
             <a:pPr algn="ctr"/>
+            <a:endParaRPr/>
           </a:p>
         </p:txBody>
       </p:sp>
@@ -16008,6 +16815,7 @@
           <a:lstStyle/>
           <a:p>
             <a:pPr algn="ctr"/>
+            <a:endParaRPr/>
           </a:p>
         </p:txBody>
       </p:sp>
@@ -16051,6 +16859,7 @@
           <a:lstStyle/>
           <a:p>
             <a:pPr algn="ctr"/>
+            <a:endParaRPr/>
           </a:p>
         </p:txBody>
       </p:sp>
@@ -16094,6 +16903,7 @@
           <a:lstStyle/>
           <a:p>
             <a:pPr algn="ctr"/>
+            <a:endParaRPr/>
           </a:p>
         </p:txBody>
       </p:sp>
@@ -16137,6 +16947,7 @@
           <a:lstStyle/>
           <a:p>
             <a:pPr algn="ctr"/>
+            <a:endParaRPr/>
           </a:p>
         </p:txBody>
       </p:sp>
@@ -16180,6 +16991,7 @@
           <a:lstStyle/>
           <a:p>
             <a:pPr algn="ctr"/>
+            <a:endParaRPr/>
           </a:p>
         </p:txBody>
       </p:sp>
@@ -16223,6 +17035,7 @@
           <a:lstStyle/>
           <a:p>
             <a:pPr algn="ctr"/>
+            <a:endParaRPr/>
           </a:p>
         </p:txBody>
       </p:sp>
@@ -16264,7 +17077,7 @@
           </a:fontRef>
         </p:style>
         <p:txBody>
-          <a:bodyPr rtlCol="0" anchor="ctr" wrap="none"/>
+          <a:bodyPr wrap="none" rtlCol="0" anchor="ctr"/>
           <a:lstStyle/>
           <a:p>
             <a:pPr algn="ctr">
@@ -16414,6 +17227,7 @@
           <a:lstStyle/>
           <a:p>
             <a:pPr algn="ctr"/>
+            <a:endParaRPr/>
           </a:p>
         </p:txBody>
       </p:sp>
@@ -16479,11 +17293,11 @@
           </a:fontRef>
         </p:style>
         <p:txBody>
-          <a:bodyPr rtlCol="0" anchor="ctr" wrap="square" lIns="228600" tIns="182880"/>
+          <a:bodyPr wrap="square" lIns="228600" tIns="182880" rtlCol="0" anchor="ctr"/>
           <a:lstStyle/>
           <a:p>
             <a:pPr algn="ctr">
-              <a:defRPr b="1" sz="1150">
+              <a:defRPr sz="1150" b="1">
                 <a:solidFill>
                   <a:srgbClr val="E11D48"/>
                 </a:solidFill>
@@ -16500,7 +17314,7 @@
               </a:spcBef>
             </a:pPr>
             <a:r>
-              <a:rPr b="1" sz="950">
+              <a:rPr sz="950" b="1">
                 <a:solidFill>
                   <a:srgbClr val="FF5C8A"/>
                 </a:solidFill>
@@ -16523,7 +17337,7 @@
               </a:spcBef>
             </a:pPr>
             <a:r>
-              <a:rPr b="1" sz="950">
+              <a:rPr sz="950" b="1">
                 <a:solidFill>
                   <a:srgbClr val="FF5C8A"/>
                 </a:solidFill>
@@ -16546,7 +17360,7 @@
               </a:spcBef>
             </a:pPr>
             <a:r>
-              <a:rPr b="1" sz="950">
+              <a:rPr sz="950" b="1">
                 <a:solidFill>
                   <a:srgbClr val="FF5C8A"/>
                 </a:solidFill>
@@ -16569,7 +17383,7 @@
               </a:spcBef>
             </a:pPr>
             <a:r>
-              <a:rPr b="1" sz="950">
+              <a:rPr sz="950" b="1">
                 <a:solidFill>
                   <a:srgbClr val="FF5C8A"/>
                 </a:solidFill>
@@ -16592,7 +17406,7 @@
               </a:spcBef>
             </a:pPr>
             <a:r>
-              <a:rPr b="1" sz="950">
+              <a:rPr sz="950" b="1">
                 <a:solidFill>
                   <a:srgbClr val="FF5C8A"/>
                 </a:solidFill>
@@ -16652,6 +17466,7 @@
           <a:lstStyle/>
           <a:p>
             <a:pPr algn="ctr"/>
+            <a:endParaRPr/>
           </a:p>
         </p:txBody>
       </p:sp>
@@ -16717,7 +17532,7 @@
           </a:fontRef>
         </p:style>
         <p:txBody>
-          <a:bodyPr rtlCol="0" anchor="ctr" wrap="square" lIns="137160" rIns="137160" tIns="109728" bIns="91440"/>
+          <a:bodyPr wrap="square" lIns="137160" tIns="109728" rIns="137160" bIns="91440" rtlCol="0" anchor="ctr"/>
           <a:lstStyle/>
           <a:p>
             <a:pPr algn="ctr">
@@ -16756,7 +17571,7 @@
 </file>
 
 <file path=ppt/slides/slide9.xml><?xml version="1.0" encoding="utf-8"?>
-<p:sld xmlns:a="http://schemas.openxmlformats.org/drawingml/2006/main" xmlns:p="http://schemas.openxmlformats.org/presentationml/2006/main" xmlns:r="http://schemas.openxmlformats.org/officeDocument/2006/relationships">
+<p:sld xmlns:a="http://schemas.openxmlformats.org/drawingml/2006/main" xmlns:r="http://schemas.openxmlformats.org/officeDocument/2006/relationships" xmlns:p="http://schemas.openxmlformats.org/presentationml/2006/main">
   <p:cSld>
     <p:spTree>
       <p:nvGrpSpPr>
@@ -16764,7 +17579,14 @@
         <p:cNvGrpSpPr/>
         <p:nvPr/>
       </p:nvGrpSpPr>
-      <p:grpSpPr/>
+      <p:grpSpPr>
+        <a:xfrm>
+          <a:off x="0" y="0"/>
+          <a:ext cx="0" cy="0"/>
+          <a:chOff x="0" y="0"/>
+          <a:chExt cx="0" cy="0"/>
+        </a:xfrm>
+      </p:grpSpPr>
       <p:sp>
         <p:nvSpPr>
           <p:cNvPr id="2" name="Rectangle 1"/>
@@ -16805,6 +17627,7 @@
           <a:lstStyle/>
           <a:p>
             <a:pPr algn="ctr"/>
+            <a:endParaRPr/>
           </a:p>
         </p:txBody>
       </p:sp>
@@ -16848,6 +17671,7 @@
           <a:lstStyle/>
           <a:p>
             <a:pPr algn="ctr"/>
+            <a:endParaRPr/>
           </a:p>
         </p:txBody>
       </p:sp>
@@ -16891,6 +17715,7 @@
           <a:lstStyle/>
           <a:p>
             <a:pPr algn="ctr"/>
+            <a:endParaRPr/>
           </a:p>
         </p:txBody>
       </p:sp>
@@ -16934,6 +17759,7 @@
           <a:lstStyle/>
           <a:p>
             <a:pPr algn="ctr"/>
+            <a:endParaRPr/>
           </a:p>
         </p:txBody>
       </p:sp>
@@ -16977,6 +17803,7 @@
           <a:lstStyle/>
           <a:p>
             <a:pPr algn="ctr"/>
+            <a:endParaRPr/>
           </a:p>
         </p:txBody>
       </p:sp>
@@ -17020,6 +17847,7 @@
           <a:lstStyle/>
           <a:p>
             <a:pPr algn="ctr"/>
+            <a:endParaRPr/>
           </a:p>
         </p:txBody>
       </p:sp>
@@ -17063,6 +17891,7 @@
           <a:lstStyle/>
           <a:p>
             <a:pPr algn="ctr"/>
+            <a:endParaRPr/>
           </a:p>
         </p:txBody>
       </p:sp>
@@ -17106,6 +17935,7 @@
           <a:lstStyle/>
           <a:p>
             <a:pPr algn="ctr"/>
+            <a:endParaRPr/>
           </a:p>
         </p:txBody>
       </p:sp>
@@ -17147,7 +17977,7 @@
           </a:fontRef>
         </p:style>
         <p:txBody>
-          <a:bodyPr rtlCol="0" anchor="ctr" wrap="none"/>
+          <a:bodyPr wrap="none" rtlCol="0" anchor="ctr"/>
           <a:lstStyle/>
           <a:p>
             <a:pPr algn="ctr">
@@ -17297,6 +18127,7 @@
           <a:lstStyle/>
           <a:p>
             <a:pPr algn="ctr"/>
+            <a:endParaRPr/>
           </a:p>
         </p:txBody>
       </p:sp>
@@ -17362,11 +18193,11 @@
           </a:fontRef>
         </p:style>
         <p:txBody>
-          <a:bodyPr rtlCol="0" anchor="ctr" wrap="square" lIns="228600" tIns="182880"/>
+          <a:bodyPr wrap="square" lIns="228600" tIns="182880" rtlCol="0" anchor="ctr"/>
           <a:lstStyle/>
           <a:p>
             <a:pPr algn="ctr">
-              <a:defRPr b="1" sz="1150">
+              <a:defRPr sz="1150" b="1">
                 <a:solidFill>
                   <a:srgbClr val="E11D48"/>
                 </a:solidFill>
@@ -17383,7 +18214,7 @@
               </a:spcBef>
             </a:pPr>
             <a:r>
-              <a:rPr b="1" sz="950">
+              <a:rPr sz="950" b="1">
                 <a:solidFill>
                   <a:srgbClr val="1E293B"/>
                 </a:solidFill>
@@ -17406,7 +18237,7 @@
               </a:spcBef>
             </a:pPr>
             <a:r>
-              <a:rPr b="1" sz="950">
+              <a:rPr sz="950" b="1">
                 <a:solidFill>
                   <a:srgbClr val="1E293B"/>
                 </a:solidFill>
@@ -17429,7 +18260,7 @@
               </a:spcBef>
             </a:pPr>
             <a:r>
-              <a:rPr b="1" sz="950">
+              <a:rPr sz="950" b="1">
                 <a:solidFill>
                   <a:srgbClr val="1E293B"/>
                 </a:solidFill>
@@ -17452,7 +18283,7 @@
               </a:spcBef>
             </a:pPr>
             <a:r>
-              <a:rPr b="1" sz="950">
+              <a:rPr sz="950" b="1">
                 <a:solidFill>
                   <a:srgbClr val="1E293B"/>
                 </a:solidFill>
@@ -17475,7 +18306,7 @@
               </a:spcBef>
             </a:pPr>
             <a:r>
-              <a:rPr b="1" sz="950">
+              <a:rPr sz="950" b="1">
                 <a:solidFill>
                   <a:srgbClr val="1E293B"/>
                 </a:solidFill>
@@ -17535,6 +18366,7 @@
           <a:lstStyle/>
           <a:p>
             <a:pPr algn="ctr"/>
+            <a:endParaRPr/>
           </a:p>
         </p:txBody>
       </p:sp>
@@ -17600,7 +18432,7 @@
           </a:fontRef>
         </p:style>
         <p:txBody>
-          <a:bodyPr rtlCol="0" anchor="ctr" wrap="square" lIns="137160" rIns="137160" tIns="109728" bIns="91440"/>
+          <a:bodyPr wrap="square" lIns="137160" tIns="109728" rIns="137160" bIns="91440" rtlCol="0" anchor="ctr"/>
           <a:lstStyle/>
           <a:p>
             <a:pPr algn="ctr">
@@ -17956,4 +18788,319 @@
   </a:objectDefaults>
   <a:extraClrSchemeLst/>
 </a:theme>
+</file>
+
+<file path=ppt/theme/theme2.xml><?xml version="1.0" encoding="utf-8"?>
+<a:theme xmlns:a="http://schemas.openxmlformats.org/drawingml/2006/main" name="Office Theme">
+  <a:themeElements>
+    <a:clrScheme name="Office">
+      <a:dk1>
+        <a:sysClr val="windowText" lastClr="000000"/>
+      </a:dk1>
+      <a:lt1>
+        <a:sysClr val="window" lastClr="FFFFFF"/>
+      </a:lt1>
+      <a:dk2>
+        <a:srgbClr val="0E2841"/>
+      </a:dk2>
+      <a:lt2>
+        <a:srgbClr val="E8E8E8"/>
+      </a:lt2>
+      <a:accent1>
+        <a:srgbClr val="156082"/>
+      </a:accent1>
+      <a:accent2>
+        <a:srgbClr val="E97132"/>
+      </a:accent2>
+      <a:accent3>
+        <a:srgbClr val="196B24"/>
+      </a:accent3>
+      <a:accent4>
+        <a:srgbClr val="0F9ED5"/>
+      </a:accent4>
+      <a:accent5>
+        <a:srgbClr val="A02B93"/>
+      </a:accent5>
+      <a:accent6>
+        <a:srgbClr val="4EA72E"/>
+      </a:accent6>
+      <a:hlink>
+        <a:srgbClr val="467886"/>
+      </a:hlink>
+      <a:folHlink>
+        <a:srgbClr val="96607D"/>
+      </a:folHlink>
+    </a:clrScheme>
+    <a:fontScheme name="Office">
+      <a:majorFont>
+        <a:latin typeface="Aptos Display" panose="02110004020202020204"/>
+        <a:ea typeface=""/>
+        <a:cs typeface=""/>
+        <a:font script="Jpan" typeface="游ゴシック Light"/>
+        <a:font script="Hang" typeface="맑은 고딕"/>
+        <a:font script="Hans" typeface="等线 Light"/>
+        <a:font script="Hant" typeface="新細明體"/>
+        <a:font script="Arab" typeface="Times New Roman"/>
+        <a:font script="Hebr" typeface="Times New Roman"/>
+        <a:font script="Thai" typeface="Angsana New"/>
+        <a:font script="Ethi" typeface="Nyala"/>
+        <a:font script="Beng" typeface="Vrinda"/>
+        <a:font script="Gujr" typeface="Shruti"/>
+        <a:font script="Khmr" typeface="MoolBoran"/>
+        <a:font script="Knda" typeface="Tunga"/>
+        <a:font script="Guru" typeface="Raavi"/>
+        <a:font script="Cans" typeface="Euphemia"/>
+        <a:font script="Cher" typeface="Plantagenet Cherokee"/>
+        <a:font script="Yiii" typeface="Microsoft Yi Baiti"/>
+        <a:font script="Tibt" typeface="Microsoft Himalaya"/>
+        <a:font script="Thaa" typeface="MV Boli"/>
+        <a:font script="Deva" typeface="Mangal"/>
+        <a:font script="Telu" typeface="Gautami"/>
+        <a:font script="Taml" typeface="Latha"/>
+        <a:font script="Syrc" typeface="Estrangelo Edessa"/>
+        <a:font script="Orya" typeface="Kalinga"/>
+        <a:font script="Mlym" typeface="Kartika"/>
+        <a:font script="Laoo" typeface="DokChampa"/>
+        <a:font script="Sinh" typeface="Iskoola Pota"/>
+        <a:font script="Mong" typeface="Mongolian Baiti"/>
+        <a:font script="Viet" typeface="Times New Roman"/>
+        <a:font script="Uigh" typeface="Microsoft Uighur"/>
+        <a:font script="Geor" typeface="Sylfaen"/>
+        <a:font script="Armn" typeface="Arial"/>
+        <a:font script="Bugi" typeface="Leelawadee UI"/>
+        <a:font script="Bopo" typeface="Microsoft JhengHei"/>
+        <a:font script="Java" typeface="Javanese Text"/>
+        <a:font script="Lisu" typeface="Segoe UI"/>
+        <a:font script="Mymr" typeface="Myanmar Text"/>
+        <a:font script="Nkoo" typeface="Ebrima"/>
+        <a:font script="Olck" typeface="Nirmala UI"/>
+        <a:font script="Osma" typeface="Ebrima"/>
+        <a:font script="Phag" typeface="Phagspa"/>
+        <a:font script="Syrn" typeface="Estrangelo Edessa"/>
+        <a:font script="Syrj" typeface="Estrangelo Edessa"/>
+        <a:font script="Syre" typeface="Estrangelo Edessa"/>
+        <a:font script="Sora" typeface="Nirmala UI"/>
+        <a:font script="Tale" typeface="Microsoft Tai Le"/>
+        <a:font script="Talu" typeface="Microsoft New Tai Lue"/>
+        <a:font script="Tfng" typeface="Ebrima"/>
+      </a:majorFont>
+      <a:minorFont>
+        <a:latin typeface="Aptos" panose="02110004020202020204"/>
+        <a:ea typeface=""/>
+        <a:cs typeface=""/>
+        <a:font script="Jpan" typeface="游ゴシック"/>
+        <a:font script="Hang" typeface="맑은 고딕"/>
+        <a:font script="Hans" typeface="等线"/>
+        <a:font script="Hant" typeface="新細明體"/>
+        <a:font script="Arab" typeface="Arial"/>
+        <a:font script="Hebr" typeface="Arial"/>
+        <a:font script="Thai" typeface="Cordia New"/>
+        <a:font script="Ethi" typeface="Nyala"/>
+        <a:font script="Beng" typeface="Vrinda"/>
+        <a:font script="Gujr" typeface="Shruti"/>
+        <a:font script="Khmr" typeface="DaunPenh"/>
+        <a:font script="Knda" typeface="Tunga"/>
+        <a:font script="Guru" typeface="Raavi"/>
+        <a:font script="Cans" typeface="Euphemia"/>
+        <a:font script="Cher" typeface="Plantagenet Cherokee"/>
+        <a:font script="Yiii" typeface="Microsoft Yi Baiti"/>
+        <a:font script="Tibt" typeface="Microsoft Himalaya"/>
+        <a:font script="Thaa" typeface="MV Boli"/>
+        <a:font script="Deva" typeface="Mangal"/>
+        <a:font script="Telu" typeface="Gautami"/>
+        <a:font script="Taml" typeface="Latha"/>
+        <a:font script="Syrc" typeface="Estrangelo Edessa"/>
+        <a:font script="Orya" typeface="Kalinga"/>
+        <a:font script="Mlym" typeface="Kartika"/>
+        <a:font script="Laoo" typeface="DokChampa"/>
+        <a:font script="Sinh" typeface="Iskoola Pota"/>
+        <a:font script="Mong" typeface="Mongolian Baiti"/>
+        <a:font script="Viet" typeface="Arial"/>
+        <a:font script="Uigh" typeface="Microsoft Uighur"/>
+        <a:font script="Geor" typeface="Sylfaen"/>
+        <a:font script="Armn" typeface="Arial"/>
+        <a:font script="Bugi" typeface="Leelawadee UI"/>
+        <a:font script="Bopo" typeface="Microsoft JhengHei"/>
+        <a:font script="Java" typeface="Javanese Text"/>
+        <a:font script="Lisu" typeface="Segoe UI"/>
+        <a:font script="Mymr" typeface="Myanmar Text"/>
+        <a:font script="Nkoo" typeface="Ebrima"/>
+        <a:font script="Olck" typeface="Nirmala UI"/>
+        <a:font script="Osma" typeface="Ebrima"/>
+        <a:font script="Phag" typeface="Phagspa"/>
+        <a:font script="Syrn" typeface="Estrangelo Edessa"/>
+        <a:font script="Syrj" typeface="Estrangelo Edessa"/>
+        <a:font script="Syre" typeface="Estrangelo Edessa"/>
+        <a:font script="Sora" typeface="Nirmala UI"/>
+        <a:font script="Tale" typeface="Microsoft Tai Le"/>
+        <a:font script="Talu" typeface="Microsoft New Tai Lue"/>
+        <a:font script="Tfng" typeface="Ebrima"/>
+      </a:minorFont>
+    </a:fontScheme>
+    <a:fmtScheme name="Office">
+      <a:fillStyleLst>
+        <a:solidFill>
+          <a:schemeClr val="phClr"/>
+        </a:solidFill>
+        <a:gradFill rotWithShape="1">
+          <a:gsLst>
+            <a:gs pos="0">
+              <a:schemeClr val="phClr">
+                <a:lumMod val="110000"/>
+                <a:satMod val="105000"/>
+                <a:tint val="67000"/>
+              </a:schemeClr>
+            </a:gs>
+            <a:gs pos="50000">
+              <a:schemeClr val="phClr">
+                <a:lumMod val="105000"/>
+                <a:satMod val="103000"/>
+                <a:tint val="73000"/>
+              </a:schemeClr>
+            </a:gs>
+            <a:gs pos="100000">
+              <a:schemeClr val="phClr">
+                <a:lumMod val="105000"/>
+                <a:satMod val="109000"/>
+                <a:tint val="81000"/>
+              </a:schemeClr>
+            </a:gs>
+          </a:gsLst>
+          <a:lin ang="5400000" scaled="0"/>
+        </a:gradFill>
+        <a:gradFill rotWithShape="1">
+          <a:gsLst>
+            <a:gs pos="0">
+              <a:schemeClr val="phClr">
+                <a:satMod val="103000"/>
+                <a:lumMod val="102000"/>
+                <a:tint val="94000"/>
+              </a:schemeClr>
+            </a:gs>
+            <a:gs pos="50000">
+              <a:schemeClr val="phClr">
+                <a:satMod val="110000"/>
+                <a:lumMod val="100000"/>
+                <a:shade val="100000"/>
+              </a:schemeClr>
+            </a:gs>
+            <a:gs pos="100000">
+              <a:schemeClr val="phClr">
+                <a:lumMod val="99000"/>
+                <a:satMod val="120000"/>
+                <a:shade val="78000"/>
+              </a:schemeClr>
+            </a:gs>
+          </a:gsLst>
+          <a:lin ang="5400000" scaled="0"/>
+        </a:gradFill>
+      </a:fillStyleLst>
+      <a:lnStyleLst>
+        <a:ln w="12700" cap="flat" cmpd="sng" algn="ctr">
+          <a:solidFill>
+            <a:schemeClr val="phClr"/>
+          </a:solidFill>
+          <a:prstDash val="solid"/>
+          <a:miter lim="800000"/>
+        </a:ln>
+        <a:ln w="19050" cap="flat" cmpd="sng" algn="ctr">
+          <a:solidFill>
+            <a:schemeClr val="phClr"/>
+          </a:solidFill>
+          <a:prstDash val="solid"/>
+          <a:miter lim="800000"/>
+        </a:ln>
+        <a:ln w="25400" cap="flat" cmpd="sng" algn="ctr">
+          <a:solidFill>
+            <a:schemeClr val="phClr"/>
+          </a:solidFill>
+          <a:prstDash val="solid"/>
+          <a:miter lim="800000"/>
+        </a:ln>
+      </a:lnStyleLst>
+      <a:effectStyleLst>
+        <a:effectStyle>
+          <a:effectLst/>
+        </a:effectStyle>
+        <a:effectStyle>
+          <a:effectLst/>
+        </a:effectStyle>
+        <a:effectStyle>
+          <a:effectLst>
+            <a:outerShdw blurRad="57150" dist="19050" dir="5400000" algn="ctr" rotWithShape="0">
+              <a:srgbClr val="000000">
+                <a:alpha val="63000"/>
+              </a:srgbClr>
+            </a:outerShdw>
+          </a:effectLst>
+        </a:effectStyle>
+      </a:effectStyleLst>
+      <a:bgFillStyleLst>
+        <a:solidFill>
+          <a:schemeClr val="phClr"/>
+        </a:solidFill>
+        <a:solidFill>
+          <a:schemeClr val="phClr">
+            <a:tint val="95000"/>
+            <a:satMod val="170000"/>
+          </a:schemeClr>
+        </a:solidFill>
+        <a:gradFill rotWithShape="1">
+          <a:gsLst>
+            <a:gs pos="0">
+              <a:schemeClr val="phClr">
+                <a:tint val="93000"/>
+                <a:satMod val="150000"/>
+                <a:shade val="98000"/>
+                <a:lumMod val="102000"/>
+              </a:schemeClr>
+            </a:gs>
+            <a:gs pos="50000">
+              <a:schemeClr val="phClr">
+                <a:tint val="98000"/>
+                <a:satMod val="130000"/>
+                <a:shade val="90000"/>
+                <a:lumMod val="103000"/>
+              </a:schemeClr>
+            </a:gs>
+            <a:gs pos="100000">
+              <a:schemeClr val="phClr">
+                <a:shade val="63000"/>
+                <a:satMod val="120000"/>
+              </a:schemeClr>
+            </a:gs>
+          </a:gsLst>
+          <a:lin ang="5400000" scaled="0"/>
+        </a:gradFill>
+      </a:bgFillStyleLst>
+    </a:fmtScheme>
+  </a:themeElements>
+  <a:objectDefaults>
+    <a:lnDef>
+      <a:spPr/>
+      <a:bodyPr/>
+      <a:lstStyle/>
+      <a:style>
+        <a:lnRef idx="2">
+          <a:schemeClr val="accent1"/>
+        </a:lnRef>
+        <a:fillRef idx="0">
+          <a:schemeClr val="accent1"/>
+        </a:fillRef>
+        <a:effectRef idx="1">
+          <a:schemeClr val="accent1"/>
+        </a:effectRef>
+        <a:fontRef idx="minor">
+          <a:schemeClr val="tx1"/>
+        </a:fontRef>
+      </a:style>
+    </a:lnDef>
+  </a:objectDefaults>
+  <a:extraClrSchemeLst/>
+  <a:extLst>
+    <a:ext uri="{05A4C25C-085E-4340-85A3-A5531E510DB2}">
+      <thm15:themeFamily xmlns:thm15="http://schemas.microsoft.com/office/thememl/2012/main" name="Office Theme" id="{2E142A2C-CD16-42D6-873A-C26D2A0506FA}" vid="{1BDDFF52-6CD6-40A5-AB3C-68EB2F1E4D0A}"/>
+    </a:ext>
+  </a:extLst>
+</a:theme>
 </file>
</xml_diff>